<commit_message>
Sim-Review VA08: 8 VPs umgesetzt + Artefakte neu + sim_review ✅
Co-Authored-By: Claude Fable 5 <noreply@anthropic.com>
</commit_message>
<xml_diff>
--- a/protected-downloads/praesentation/VA08.pptx
+++ b/protected-downloads/praesentation/VA08.pptx
@@ -5333,14 +5333,14 @@
           <a:p>
             <a:pPr>
               <a:spcBef>
-                <a:spcPts val="700"/>
+                <a:spcPts val="400"/>
               </a:spcBef>
               <a:spcAft>
                 <a:spcPts val="100"/>
               </a:spcAft>
             </a:pPr>
             <a:r>
-              <a:rPr sz="1200">
+              <a:rPr sz="900">
                 <a:solidFill>
                   <a:srgbClr val="78808C"/>
                 </a:solidFill>
@@ -5349,7 +5349,7 @@
               <a:t>00:00–00:05 </a:t>
             </a:r>
             <a:r>
-              <a:rPr sz="1500" b="1">
+              <a:rPr sz="1200" b="1">
                 <a:solidFill>
                   <a:srgbClr val="3D5466"/>
                 </a:solidFill>
@@ -5358,7 +5358,7 @@
               <a:t>  Begrüßung &amp; Einstieg</a:t>
             </a:r>
             <a:r>
-              <a:rPr sz="1200">
+              <a:rPr sz="900">
                 <a:solidFill>
                   <a:srgbClr val="78808C"/>
                 </a:solidFill>
@@ -5370,14 +5370,14 @@
           <a:p>
             <a:pPr>
               <a:spcBef>
-                <a:spcPts val="700"/>
+                <a:spcPts val="400"/>
               </a:spcBef>
               <a:spcAft>
                 <a:spcPts val="100"/>
               </a:spcAft>
             </a:pPr>
             <a:r>
-              <a:rPr sz="1200">
+              <a:rPr sz="900">
                 <a:solidFill>
                   <a:srgbClr val="78808C"/>
                 </a:solidFill>
@@ -5386,7 +5386,7 @@
               <a:t>00:05–00:20 </a:t>
             </a:r>
             <a:r>
-              <a:rPr sz="1500" b="1">
+              <a:rPr sz="1200" b="1">
                 <a:solidFill>
                   <a:srgbClr val="3D5466"/>
                 </a:solidFill>
@@ -5395,7 +5395,7 @@
               <a:t>  Theorie-Input 1: Wichtigkeit vs. Dringlichkeit</a:t>
             </a:r>
             <a:r>
-              <a:rPr sz="1200">
+              <a:rPr sz="900">
                 <a:solidFill>
                   <a:srgbClr val="78808C"/>
                 </a:solidFill>
@@ -5407,14 +5407,14 @@
           <a:p>
             <a:pPr>
               <a:spcBef>
-                <a:spcPts val="700"/>
+                <a:spcPts val="400"/>
               </a:spcBef>
               <a:spcAft>
                 <a:spcPts val="100"/>
               </a:spcAft>
             </a:pPr>
             <a:r>
-              <a:rPr sz="1200">
+              <a:rPr sz="900">
                 <a:solidFill>
                   <a:srgbClr val="78808C"/>
                 </a:solidFill>
@@ -5423,7 +5423,7 @@
               <a:t>00:20–00:30 </a:t>
             </a:r>
             <a:r>
-              <a:rPr sz="1500" b="1">
+              <a:rPr sz="1200" b="1">
                 <a:solidFill>
                   <a:srgbClr val="3D5466"/>
                 </a:solidFill>
@@ -5432,7 +5432,7 @@
               <a:t>  Theorie-Input 2: Zeitfresser &amp; Bearbeitungsblöcke</a:t>
             </a:r>
             <a:r>
-              <a:rPr sz="1200">
+              <a:rPr sz="900">
                 <a:solidFill>
                   <a:srgbClr val="78808C"/>
                 </a:solidFill>
@@ -5444,14 +5444,14 @@
           <a:p>
             <a:pPr>
               <a:spcBef>
-                <a:spcPts val="700"/>
+                <a:spcPts val="400"/>
               </a:spcBef>
               <a:spcAft>
                 <a:spcPts val="100"/>
               </a:spcAft>
             </a:pPr>
             <a:r>
-              <a:rPr sz="1200">
+              <a:rPr sz="900">
                 <a:solidFill>
                   <a:srgbClr val="78808C"/>
                 </a:solidFill>
@@ -5460,7 +5460,7 @@
               <a:t>00:30–00:35 </a:t>
             </a:r>
             <a:r>
-              <a:rPr sz="1500" b="1">
+              <a:rPr sz="1200" b="1">
                 <a:solidFill>
                   <a:srgbClr val="3D5466"/>
                 </a:solidFill>
@@ -5469,7 +5469,7 @@
               <a:t>  Fallübergabe</a:t>
             </a:r>
             <a:r>
-              <a:rPr sz="1200">
+              <a:rPr sz="900">
                 <a:solidFill>
                   <a:srgbClr val="78808C"/>
                 </a:solidFill>
@@ -5481,14 +5481,14 @@
           <a:p>
             <a:pPr>
               <a:spcBef>
-                <a:spcPts val="700"/>
+                <a:spcPts val="400"/>
               </a:spcBef>
               <a:spcAft>
                 <a:spcPts val="100"/>
               </a:spcAft>
             </a:pPr>
             <a:r>
-              <a:rPr sz="1200">
+              <a:rPr sz="900">
                 <a:solidFill>
                   <a:srgbClr val="78808C"/>
                 </a:solidFill>
@@ -5497,7 +5497,7 @@
               <a:t>00:35–00:50 </a:t>
             </a:r>
             <a:r>
-              <a:rPr sz="1500" b="1">
+              <a:rPr sz="1200" b="1">
                 <a:solidFill>
                   <a:srgbClr val="3D5466"/>
                 </a:solidFill>
@@ -5506,7 +5506,7 @@
               <a:t>  AB-1 &amp; AB-2 in Einzelarbeit</a:t>
             </a:r>
             <a:r>
-              <a:rPr sz="1200">
+              <a:rPr sz="900">
                 <a:solidFill>
                   <a:srgbClr val="78808C"/>
                 </a:solidFill>
@@ -5518,14 +5518,14 @@
           <a:p>
             <a:pPr>
               <a:spcBef>
-                <a:spcPts val="700"/>
+                <a:spcPts val="400"/>
               </a:spcBef>
               <a:spcAft>
                 <a:spcPts val="100"/>
               </a:spcAft>
             </a:pPr>
             <a:r>
-              <a:rPr sz="1200">
+              <a:rPr sz="900">
                 <a:solidFill>
                   <a:srgbClr val="78808C"/>
                 </a:solidFill>
@@ -5534,7 +5534,7 @@
               <a:t>00:50–01:05 </a:t>
             </a:r>
             <a:r>
-              <a:rPr sz="1500" b="1">
+              <a:rPr sz="1200" b="1">
                 <a:solidFill>
                   <a:srgbClr val="3D5466"/>
                 </a:solidFill>
@@ -5543,7 +5543,7 @@
               <a:t>  Plenumsbesprechung AB-1/AB-2</a:t>
             </a:r>
             <a:r>
-              <a:rPr sz="1200">
+              <a:rPr sz="900">
                 <a:solidFill>
                   <a:srgbClr val="78808C"/>
                 </a:solidFill>
@@ -5555,23 +5555,23 @@
           <a:p>
             <a:pPr>
               <a:spcBef>
-                <a:spcPts val="700"/>
+                <a:spcPts val="400"/>
               </a:spcBef>
               <a:spcAft>
                 <a:spcPts val="100"/>
               </a:spcAft>
             </a:pPr>
             <a:r>
-              <a:rPr sz="1200">
+              <a:rPr sz="900">
                 <a:solidFill>
                   <a:srgbClr val="78808C"/>
                 </a:solidFill>
                 <a:latin typeface="Consolas"/>
               </a:rPr>
-              <a:t>01:05–01:15 </a:t>
-            </a:r>
-            <a:r>
-              <a:rPr sz="1500" b="1">
+              <a:t>01:05–01:17 </a:t>
+            </a:r>
+            <a:r>
+              <a:rPr sz="1200" b="1">
                 <a:solidFill>
                   <a:srgbClr val="3D5466"/>
                 </a:solidFill>
@@ -5580,7 +5580,7 @@
               <a:t>  AB-3 &amp; AB-4</a:t>
             </a:r>
             <a:r>
-              <a:rPr sz="1200">
+              <a:rPr sz="900">
                 <a:solidFill>
                   <a:srgbClr val="78808C"/>
                 </a:solidFill>
@@ -5592,32 +5592,32 @@
           <a:p>
             <a:pPr>
               <a:spcBef>
-                <a:spcPts val="700"/>
+                <a:spcPts val="400"/>
               </a:spcBef>
               <a:spcAft>
                 <a:spcPts val="100"/>
               </a:spcAft>
             </a:pPr>
             <a:r>
-              <a:rPr sz="1200">
+              <a:rPr sz="900">
                 <a:solidFill>
                   <a:srgbClr val="78808C"/>
                 </a:solidFill>
                 <a:latin typeface="Consolas"/>
               </a:rPr>
-              <a:t>01:15–01:25 </a:t>
-            </a:r>
-            <a:r>
-              <a:rPr sz="1500" b="1">
+              <a:t>01:17–01:24 </a:t>
+            </a:r>
+            <a:r>
+              <a:rPr sz="1200" b="1">
                 <a:solidFill>
                   <a:srgbClr val="3D5466"/>
                 </a:solidFill>
                 <a:latin typeface="Arial"/>
               </a:rPr>
-              <a:t>  Reflexion &amp; Transfer</a:t>
-            </a:r>
-            <a:r>
-              <a:rPr sz="1200">
+              <a:t>  Reflexion</a:t>
+            </a:r>
+            <a:r>
+              <a:rPr sz="900">
                 <a:solidFill>
                   <a:srgbClr val="78808C"/>
                 </a:solidFill>
@@ -5629,32 +5629,69 @@
           <a:p>
             <a:pPr>
               <a:spcBef>
-                <a:spcPts val="700"/>
+                <a:spcPts val="400"/>
               </a:spcBef>
               <a:spcAft>
                 <a:spcPts val="100"/>
               </a:spcAft>
             </a:pPr>
             <a:r>
-              <a:rPr sz="1200">
+              <a:rPr sz="900">
                 <a:solidFill>
                   <a:srgbClr val="78808C"/>
                 </a:solidFill>
                 <a:latin typeface="Consolas"/>
               </a:rPr>
-              <a:t>01:25–01:30 </a:t>
-            </a:r>
-            <a:r>
-              <a:rPr sz="1500" b="1">
+              <a:t>01:24–01:27 </a:t>
+            </a:r>
+            <a:r>
+              <a:rPr sz="1200" b="1">
                 <a:solidFill>
                   <a:srgbClr val="3D5466"/>
                 </a:solidFill>
                 <a:latin typeface="Arial"/>
               </a:rPr>
+              <a:t>  Transfer-Anker</a:t>
+            </a:r>
+            <a:r>
+              <a:rPr sz="900">
+                <a:solidFill>
+                  <a:srgbClr val="78808C"/>
+                </a:solidFill>
+                <a:latin typeface="Arial"/>
+              </a:rPr>
+              <a:t>  ·  Einzelarbeit + Plenum</a:t>
+            </a:r>
+          </a:p>
+          <a:p>
+            <a:pPr>
+              <a:spcBef>
+                <a:spcPts val="400"/>
+              </a:spcBef>
+              <a:spcAft>
+                <a:spcPts val="100"/>
+              </a:spcAft>
+            </a:pPr>
+            <a:r>
+              <a:rPr sz="900">
+                <a:solidFill>
+                  <a:srgbClr val="78808C"/>
+                </a:solidFill>
+                <a:latin typeface="Consolas"/>
+              </a:rPr>
+              <a:t>01:27–01:30 </a:t>
+            </a:r>
+            <a:r>
+              <a:rPr sz="1200" b="1">
+                <a:solidFill>
+                  <a:srgbClr val="3D5466"/>
+                </a:solidFill>
+                <a:latin typeface="Arial"/>
+              </a:rPr>
               <a:t>  Abschluss &amp; Ausblick</a:t>
             </a:r>
             <a:r>
-              <a:rPr sz="1200">
+              <a:rPr sz="900">
                 <a:solidFill>
                   <a:srgbClr val="78808C"/>
                 </a:solidFill>

</xml_diff>

<commit_message>
Welle 3: VA08 kuratiertes Deck + 2 Schaubilder (Web/Admin/Workbook)
Co-Authored-By: Claude Fable 5 <noreply@anthropic.com>
</commit_message>
<xml_diff>
--- a/protected-downloads/praesentation/VA08.pptx
+++ b/protected-downloads/praesentation/VA08.pptx
@@ -13,6 +13,14 @@
     <p:sldId id="261" r:id="rId13"/>
     <p:sldId id="262" r:id="rId14"/>
     <p:sldId id="263" r:id="rId15"/>
+    <p:sldId id="264" r:id="rId16"/>
+    <p:sldId id="265" r:id="rId17"/>
+    <p:sldId id="266" r:id="rId18"/>
+    <p:sldId id="267" r:id="rId19"/>
+    <p:sldId id="268" r:id="rId20"/>
+    <p:sldId id="269" r:id="rId21"/>
+    <p:sldId id="270" r:id="rId22"/>
+    <p:sldId id="271" r:id="rId23"/>
   </p:sldIdLst>
   <p:sldSz cx="12188952" cy="6858000" type="screen4x3"/>
   <p:notesSz cx="6858000" cy="9144000"/>
@@ -579,7 +587,7 @@
           <a:lstStyle/>
           <a:p>
             <a:r>
-              <a:t>Siehe Trainerhandbuch (Sektion 3) für Moderationshinweise, Timing und erwartete Teilnehmerreaktionen.</a:t>
+              <a:t>Einstieg: „Was war Ihre letzte Woche – geplant oder reaktiv?" (Handzeichen). Wichtigkeits-Frage stellen: „Was ist der Unterschied zwischen einer lauten und einer wichtigen Aufgabe?"</a:t>
             </a:r>
           </a:p>
         </p:txBody>
@@ -649,22 +657,7 @@
           <a:lstStyle/>
           <a:p>
             <a:r>
-              <a:t>AB-2 Musterlösung (Trainer-Version)</a:t>
-            </a:r>
-          </a:p>
-          <a:p>
-            <a:r>
-              <a:t>Sinnvolle Reihenfolge: (1) 2-Minuten-Mail der Kundin sofort beantworten (schnell weg, schafft Ruhe). (2) Engagementübersicht für 11:00 – wichtig und dringend, mit hartem Termin → früh einplanen. (3) Fällige Wiedervorlagen abarbeiten (wichtig + dringend, gebündelt). (4) Quartals-Datenpflege terminieren (wichtig, nicht dringend) – fest in die Woche legen, nicht „mal machen". Telefon: in den Bearbeitungsblöcken bewusst steuern (Anrufbeantworter/Vertretung), sonst zerfasert der Vormittag.</a:t>
-            </a:r>
-          </a:p>
-          <a:p>
-            <a:r>
-              <a:t>Kernbefund: Der harte Termin (11:00) und die 2-Minuten-Regel strukturieren den Vormittag. Die Datenpflege ist die typische „wichtig, nicht dringend"-Aufgabe, die ohne festen Termin liegen bleibt.</a:t>
-            </a:r>
-          </a:p>
-          <a:p>
-            <a:r>
-              <a:t>Trainer-Hinweis: Die „richtige" Reihenfolge ist weniger wichtig als die Begründung. Achten Sie darauf, dass Teilnehmer den harten Termin früh sichern und die nicht-dringende Datenpflege aktiv terminieren statt verschieben.</a:t>
+              <a:t>Vier-Felder-Matrix gemeinsam am Flipchart entwickeln. Wichtigkeit operationalisieren: Auswirkung auf Fristen, Kunden, Prozessqualität, Haftung.</a:t>
             </a:r>
           </a:p>
         </p:txBody>
@@ -734,7 +727,367 @@
           <a:lstStyle/>
           <a:p>
             <a:r>
-              <a:t>Siehe Trainerhandbuch (Sektion 3) für Moderationshinweise, Timing und erwartete Teilnehmerreaktionen.</a:t>
+              <a:t>Praxishinweis: der Block funktioniert nur mit geregeltem Telefon. Die Teamleitung einmalig ansprechen – das ist Prozessoptimierung, kein Sonderwunsch.</a:t>
+            </a:r>
+          </a:p>
+        </p:txBody>
+      </p:sp>
+      <p:sp>
+        <p:nvSpPr>
+          <p:cNvPr id="4" name="Slide Number Placeholder 3"/>
+          <p:cNvSpPr>
+            <a:spLocks noGrp="1"/>
+          </p:cNvSpPr>
+          <p:nvPr>
+            <p:ph type="sldNum" idx="5" sz="quarter"/>
+          </p:nvPr>
+        </p:nvSpPr>
+        <p:spPr/>
+      </p:sp>
+    </p:spTree>
+  </p:cSld>
+  <p:clrMapOvr>
+    <a:masterClrMapping/>
+  </p:clrMapOvr>
+</p:notes>
+</file>
+
+<file path=ppt/notesSlides/notesSlide5.xml><?xml version="1.0" encoding="utf-8"?>
+<p:notes xmlns:a="http://schemas.openxmlformats.org/drawingml/2006/main" xmlns:p="http://schemas.openxmlformats.org/presentationml/2006/main" xmlns:r="http://schemas.openxmlformats.org/officeDocument/2006/relationships">
+  <p:cSld>
+    <p:spTree>
+      <p:nvGrpSpPr>
+        <p:cNvPr id="1" name=""/>
+        <p:cNvGrpSpPr/>
+        <p:nvPr/>
+      </p:nvGrpSpPr>
+      <p:grpSpPr>
+        <a:xfrm>
+          <a:off x="0" y="0"/>
+          <a:ext cx="0" cy="0"/>
+          <a:chOff x="0" y="0"/>
+          <a:chExt cx="0" cy="0"/>
+        </a:xfrm>
+      </p:grpSpPr>
+      <p:sp>
+        <p:nvSpPr>
+          <p:cNvPr id="2" name="Slide Image Placeholder 1"/>
+          <p:cNvSpPr>
+            <a:spLocks noGrp="1"/>
+          </p:cNvSpPr>
+          <p:nvPr>
+            <p:ph type="sldImg" idx="2"/>
+          </p:nvPr>
+        </p:nvSpPr>
+        <p:spPr/>
+      </p:sp>
+      <p:sp>
+        <p:nvSpPr>
+          <p:cNvPr id="3" name="Notes Placeholder 2"/>
+          <p:cNvSpPr>
+            <a:spLocks noGrp="1"/>
+          </p:cNvSpPr>
+          <p:nvPr>
+            <p:ph type="body" idx="3" sz="quarter"/>
+          </p:nvPr>
+        </p:nvSpPr>
+        <p:spPr/>
+        <p:txBody>
+          <a:bodyPr/>
+          <a:lstStyle/>
+          <a:p>
+            <a:r>
+              <a:t>Beobachten: Wer priorisiert nach hartem Termin (11:00), wer nach Lautstärke? Kernbefunde: 11:00 schlägt generelle Dringlichkeit; 2-Minuten-Mail sofort; Datenpflege terminieren, nicht verschieben.</a:t>
+            </a:r>
+          </a:p>
+        </p:txBody>
+      </p:sp>
+      <p:sp>
+        <p:nvSpPr>
+          <p:cNvPr id="4" name="Slide Number Placeholder 3"/>
+          <p:cNvSpPr>
+            <a:spLocks noGrp="1"/>
+          </p:cNvSpPr>
+          <p:nvPr>
+            <p:ph type="sldNum" idx="5" sz="quarter"/>
+          </p:nvPr>
+        </p:nvSpPr>
+        <p:spPr/>
+      </p:sp>
+    </p:spTree>
+  </p:cSld>
+  <p:clrMapOvr>
+    <a:masterClrMapping/>
+  </p:clrMapOvr>
+</p:notes>
+</file>
+
+<file path=ppt/notesSlides/notesSlide6.xml><?xml version="1.0" encoding="utf-8"?>
+<p:notes xmlns:a="http://schemas.openxmlformats.org/drawingml/2006/main" xmlns:p="http://schemas.openxmlformats.org/presentationml/2006/main" xmlns:r="http://schemas.openxmlformats.org/officeDocument/2006/relationships">
+  <p:cSld>
+    <p:spTree>
+      <p:nvGrpSpPr>
+        <p:cNvPr id="1" name=""/>
+        <p:cNvGrpSpPr/>
+        <p:nvPr/>
+      </p:nvGrpSpPr>
+      <p:grpSpPr>
+        <a:xfrm>
+          <a:off x="0" y="0"/>
+          <a:ext cx="0" cy="0"/>
+          <a:chOff x="0" y="0"/>
+          <a:chExt cx="0" cy="0"/>
+        </a:xfrm>
+      </p:grpSpPr>
+      <p:sp>
+        <p:nvSpPr>
+          <p:cNvPr id="2" name="Slide Image Placeholder 1"/>
+          <p:cNvSpPr>
+            <a:spLocks noGrp="1"/>
+          </p:cNvSpPr>
+          <p:nvPr>
+            <p:ph type="sldImg" idx="2"/>
+          </p:nvPr>
+        </p:nvSpPr>
+        <p:spPr/>
+      </p:sp>
+      <p:sp>
+        <p:nvSpPr>
+          <p:cNvPr id="3" name="Notes Placeholder 2"/>
+          <p:cNvSpPr>
+            <a:spLocks noGrp="1"/>
+          </p:cNvSpPr>
+          <p:nvPr>
+            <p:ph type="body" idx="3" sz="quarter"/>
+          </p:nvPr>
+        </p:nvSpPr>
+        <p:spPr/>
+        <p:txBody>
+          <a:bodyPr/>
+          <a:lstStyle/>
+          <a:p>
+            <a:r>
+              <a:t>Ein harter Termin (11:00) schlägt generelle Dringlichkeit. Der Bearbeitungsblock braucht die Freigabe der Teamleitung – fast jede stimmt zu, wenn es als Prozessoptimierung vorgelegt wird.</a:t>
+            </a:r>
+          </a:p>
+        </p:txBody>
+      </p:sp>
+      <p:sp>
+        <p:nvSpPr>
+          <p:cNvPr id="4" name="Slide Number Placeholder 3"/>
+          <p:cNvSpPr>
+            <a:spLocks noGrp="1"/>
+          </p:cNvSpPr>
+          <p:nvPr>
+            <p:ph type="sldNum" idx="5" sz="quarter"/>
+          </p:nvPr>
+        </p:nvSpPr>
+        <p:spPr/>
+      </p:sp>
+    </p:spTree>
+  </p:cSld>
+  <p:clrMapOvr>
+    <a:masterClrMapping/>
+  </p:clrMapOvr>
+</p:notes>
+</file>
+
+<file path=ppt/notesSlides/notesSlide7.xml><?xml version="1.0" encoding="utf-8"?>
+<p:notes xmlns:a="http://schemas.openxmlformats.org/drawingml/2006/main" xmlns:p="http://schemas.openxmlformats.org/presentationml/2006/main" xmlns:r="http://schemas.openxmlformats.org/officeDocument/2006/relationships">
+  <p:cSld>
+    <p:spTree>
+      <p:nvGrpSpPr>
+        <p:cNvPr id="1" name=""/>
+        <p:cNvGrpSpPr/>
+        <p:nvPr/>
+      </p:nvGrpSpPr>
+      <p:grpSpPr>
+        <a:xfrm>
+          <a:off x="0" y="0"/>
+          <a:ext cx="0" cy="0"/>
+          <a:chOff x="0" y="0"/>
+          <a:chExt cx="0" cy="0"/>
+        </a:xfrm>
+      </p:grpSpPr>
+      <p:sp>
+        <p:nvSpPr>
+          <p:cNvPr id="2" name="Slide Image Placeholder 1"/>
+          <p:cNvSpPr>
+            <a:spLocks noGrp="1"/>
+          </p:cNvSpPr>
+          <p:nvPr>
+            <p:ph type="sldImg" idx="2"/>
+          </p:nvPr>
+        </p:nvSpPr>
+        <p:spPr/>
+      </p:sp>
+      <p:sp>
+        <p:nvSpPr>
+          <p:cNvPr id="3" name="Notes Placeholder 2"/>
+          <p:cNvSpPr>
+            <a:spLocks noGrp="1"/>
+          </p:cNvSpPr>
+          <p:nvPr>
+            <p:ph type="body" idx="3" sz="quarter"/>
+          </p:nvPr>
+        </p:nvSpPr>
+        <p:spPr/>
+        <p:txBody>
+          <a:bodyPr/>
+          <a:lstStyle/>
+          <a:p>
+            <a:r>
+              <a:t>AB-2 Musterlösung (Trainer-Version)</a:t>
+            </a:r>
+          </a:p>
+          <a:p>
+            <a:r>
+              <a:t>Reihenfolge: 1. 2-Minuten-Mail (sofort), 2. Engagementübersicht (harter Termin 11:00), 3. Wiedervorlagen bündeln, 4. Datenpflege terminieren. Telefon durchgehend geregelt abfangen.</a:t>
+            </a:r>
+          </a:p>
+          <a:p>
+            <a:r>
+              <a:t>Trainer-Hinweis: der harte Termin schlägt generelle Dringlichkeit; Datenpflege wird terminiert, nicht verschoben.</a:t>
+            </a:r>
+          </a:p>
+        </p:txBody>
+      </p:sp>
+      <p:sp>
+        <p:nvSpPr>
+          <p:cNvPr id="4" name="Slide Number Placeholder 3"/>
+          <p:cNvSpPr>
+            <a:spLocks noGrp="1"/>
+          </p:cNvSpPr>
+          <p:nvPr>
+            <p:ph type="sldNum" idx="5" sz="quarter"/>
+          </p:nvPr>
+        </p:nvSpPr>
+        <p:spPr/>
+      </p:sp>
+    </p:spTree>
+  </p:cSld>
+  <p:clrMapOvr>
+    <a:masterClrMapping/>
+  </p:clrMapOvr>
+</p:notes>
+</file>
+
+<file path=ppt/notesSlides/notesSlide8.xml><?xml version="1.0" encoding="utf-8"?>
+<p:notes xmlns:a="http://schemas.openxmlformats.org/drawingml/2006/main" xmlns:p="http://schemas.openxmlformats.org/presentationml/2006/main" xmlns:r="http://schemas.openxmlformats.org/officeDocument/2006/relationships">
+  <p:cSld>
+    <p:spTree>
+      <p:nvGrpSpPr>
+        <p:cNvPr id="1" name=""/>
+        <p:cNvGrpSpPr/>
+        <p:nvPr/>
+      </p:nvGrpSpPr>
+      <p:grpSpPr>
+        <a:xfrm>
+          <a:off x="0" y="0"/>
+          <a:ext cx="0" cy="0"/>
+          <a:chOff x="0" y="0"/>
+          <a:chExt cx="0" cy="0"/>
+        </a:xfrm>
+      </p:grpSpPr>
+      <p:sp>
+        <p:nvSpPr>
+          <p:cNvPr id="2" name="Slide Image Placeholder 1"/>
+          <p:cNvSpPr>
+            <a:spLocks noGrp="1"/>
+          </p:cNvSpPr>
+          <p:nvPr>
+            <p:ph type="sldImg" idx="2"/>
+          </p:nvPr>
+        </p:nvSpPr>
+        <p:spPr/>
+      </p:sp>
+      <p:sp>
+        <p:nvSpPr>
+          <p:cNvPr id="3" name="Notes Placeholder 2"/>
+          <p:cNvSpPr>
+            <a:spLocks noGrp="1"/>
+          </p:cNvSpPr>
+          <p:nvPr>
+            <p:ph type="body" idx="3" sz="quarter"/>
+          </p:nvPr>
+        </p:nvSpPr>
+        <p:spPr/>
+        <p:txBody>
+          <a:bodyPr/>
+          <a:lstStyle/>
+          <a:p>
+            <a:r>
+              <a:t>Transfer-Anker: Sec 5.1 – eine konkrete Veränderung für morgen früh aufschreiben UND den Namen der Person, der man es sagt. Ausblick VA07 (Schnittstelle).</a:t>
+            </a:r>
+          </a:p>
+        </p:txBody>
+      </p:sp>
+      <p:sp>
+        <p:nvSpPr>
+          <p:cNvPr id="4" name="Slide Number Placeholder 3"/>
+          <p:cNvSpPr>
+            <a:spLocks noGrp="1"/>
+          </p:cNvSpPr>
+          <p:nvPr>
+            <p:ph type="sldNum" idx="5" sz="quarter"/>
+          </p:nvPr>
+        </p:nvSpPr>
+        <p:spPr/>
+      </p:sp>
+    </p:spTree>
+  </p:cSld>
+  <p:clrMapOvr>
+    <a:masterClrMapping/>
+  </p:clrMapOvr>
+</p:notes>
+</file>
+
+<file path=ppt/notesSlides/notesSlide9.xml><?xml version="1.0" encoding="utf-8"?>
+<p:notes xmlns:a="http://schemas.openxmlformats.org/drawingml/2006/main" xmlns:p="http://schemas.openxmlformats.org/presentationml/2006/main" xmlns:r="http://schemas.openxmlformats.org/officeDocument/2006/relationships">
+  <p:cSld>
+    <p:spTree>
+      <p:nvGrpSpPr>
+        <p:cNvPr id="1" name=""/>
+        <p:cNvGrpSpPr/>
+        <p:nvPr/>
+      </p:nvGrpSpPr>
+      <p:grpSpPr>
+        <a:xfrm>
+          <a:off x="0" y="0"/>
+          <a:ext cx="0" cy="0"/>
+          <a:chOff x="0" y="0"/>
+          <a:chExt cx="0" cy="0"/>
+        </a:xfrm>
+      </p:grpSpPr>
+      <p:sp>
+        <p:nvSpPr>
+          <p:cNvPr id="2" name="Slide Image Placeholder 1"/>
+          <p:cNvSpPr>
+            <a:spLocks noGrp="1"/>
+          </p:cNvSpPr>
+          <p:nvPr>
+            <p:ph type="sldImg" idx="2"/>
+          </p:nvPr>
+        </p:nvSpPr>
+        <p:spPr/>
+      </p:sp>
+      <p:sp>
+        <p:nvSpPr>
+          <p:cNvPr id="3" name="Notes Placeholder 2"/>
+          <p:cNvSpPr>
+            <a:spLocks noGrp="1"/>
+          </p:cNvSpPr>
+          <p:nvPr>
+            <p:ph type="body" idx="3" sz="quarter"/>
+          </p:nvPr>
+        </p:nvSpPr>
+        <p:spPr/>
+        <p:txBody>
+          <a:bodyPr/>
+          <a:lstStyle/>
+          <a:p>
+            <a:r>
+              <a:t>Fragen 1 und 3 gemeinsam besprechen. Karte „Prioritäten &amp; Selbststeuerung" (AB-5) übergeben.</a:t>
             </a:r>
           </a:p>
         </p:txBody>
@@ -4305,6 +4658,2829 @@
 </p:sld>
 </file>
 
+<file path=ppt/slides/slide10.xml><?xml version="1.0" encoding="utf-8"?>
+<p:sld xmlns:a="http://schemas.openxmlformats.org/drawingml/2006/main" xmlns:p="http://schemas.openxmlformats.org/presentationml/2006/main" xmlns:r="http://schemas.openxmlformats.org/officeDocument/2006/relationships">
+  <p:cSld>
+    <p:spTree>
+      <p:nvGrpSpPr>
+        <p:cNvPr id="1" name=""/>
+        <p:cNvGrpSpPr/>
+        <p:nvPr/>
+      </p:nvGrpSpPr>
+      <p:grpSpPr/>
+      <p:sp>
+        <p:nvSpPr>
+          <p:cNvPr id="2" name="Rectangle 1"/>
+          <p:cNvSpPr/>
+          <p:nvPr/>
+        </p:nvSpPr>
+        <p:spPr>
+          <a:xfrm>
+            <a:off x="0" y="0"/>
+            <a:ext cx="12188952" cy="6858000"/>
+          </a:xfrm>
+          <a:prstGeom prst="rect">
+            <a:avLst/>
+          </a:prstGeom>
+          <a:solidFill>
+            <a:srgbClr val="FFFFFF"/>
+          </a:solidFill>
+          <a:ln>
+            <a:noFill/>
+          </a:ln>
+        </p:spPr>
+        <p:style>
+          <a:lnRef idx="1">
+            <a:schemeClr val="accent1"/>
+          </a:lnRef>
+          <a:fillRef idx="3">
+            <a:schemeClr val="accent1"/>
+          </a:fillRef>
+          <a:effectRef idx="2">
+            <a:schemeClr val="accent1"/>
+          </a:effectRef>
+          <a:fontRef idx="minor">
+            <a:schemeClr val="lt1"/>
+          </a:fontRef>
+        </p:style>
+        <p:txBody>
+          <a:bodyPr rtlCol="0" anchor="ctr"/>
+          <a:lstStyle/>
+          <a:p>
+            <a:pPr algn="ctr"/>
+          </a:p>
+        </p:txBody>
+      </p:sp>
+      <p:sp>
+        <p:nvSpPr>
+          <p:cNvPr id="3" name="Rectangle 2"/>
+          <p:cNvSpPr/>
+          <p:nvPr/>
+        </p:nvSpPr>
+        <p:spPr>
+          <a:xfrm>
+            <a:off x="0" y="0"/>
+            <a:ext cx="12188952" cy="50292"/>
+          </a:xfrm>
+          <a:prstGeom prst="rect">
+            <a:avLst/>
+          </a:prstGeom>
+          <a:solidFill>
+            <a:srgbClr val="1F2C56"/>
+          </a:solidFill>
+          <a:ln>
+            <a:noFill/>
+          </a:ln>
+        </p:spPr>
+        <p:style>
+          <a:lnRef idx="1">
+            <a:schemeClr val="accent1"/>
+          </a:lnRef>
+          <a:fillRef idx="3">
+            <a:schemeClr val="accent1"/>
+          </a:fillRef>
+          <a:effectRef idx="2">
+            <a:schemeClr val="accent1"/>
+          </a:effectRef>
+          <a:fontRef idx="minor">
+            <a:schemeClr val="lt1"/>
+          </a:fontRef>
+        </p:style>
+        <p:txBody>
+          <a:bodyPr rtlCol="0" anchor="ctr"/>
+          <a:lstStyle/>
+          <a:p>
+            <a:pPr algn="ctr"/>
+          </a:p>
+        </p:txBody>
+      </p:sp>
+      <p:sp>
+        <p:nvSpPr>
+          <p:cNvPr id="4" name="TextBox 3"/>
+          <p:cNvSpPr txBox="1"/>
+          <p:nvPr/>
+        </p:nvSpPr>
+        <p:spPr>
+          <a:xfrm>
+            <a:off x="685800" y="109728"/>
+            <a:ext cx="10817352" cy="228600"/>
+          </a:xfrm>
+          <a:prstGeom prst="rect">
+            <a:avLst/>
+          </a:prstGeom>
+          <a:noFill/>
+        </p:spPr>
+        <p:txBody>
+          <a:bodyPr wrap="none">
+            <a:spAutoFit/>
+          </a:bodyPr>
+          <a:lstStyle/>
+          <a:p>
+            <a:pPr algn="l"/>
+            <a:r>
+              <a:rPr sz="750">
+                <a:solidFill>
+                  <a:srgbClr val="78808C"/>
+                </a:solidFill>
+                <a:latin typeface="Consolas"/>
+              </a:rPr>
+              <a:t>VA08  ·  SCHAUBILD</a:t>
+            </a:r>
+          </a:p>
+        </p:txBody>
+      </p:sp>
+      <p:sp>
+        <p:nvSpPr>
+          <p:cNvPr id="5" name="TextBox 4"/>
+          <p:cNvSpPr txBox="1"/>
+          <p:nvPr/>
+        </p:nvSpPr>
+        <p:spPr>
+          <a:xfrm>
+            <a:off x="685800" y="502920"/>
+            <a:ext cx="10817352" cy="594360"/>
+          </a:xfrm>
+          <a:prstGeom prst="rect">
+            <a:avLst/>
+          </a:prstGeom>
+          <a:noFill/>
+        </p:spPr>
+        <p:txBody>
+          <a:bodyPr wrap="square">
+            <a:spAutoFit/>
+          </a:bodyPr>
+          <a:lstStyle/>
+          <a:p>
+            <a:pPr algn="l"/>
+            <a:r>
+              <a:rPr sz="2000" b="1" i="0">
+                <a:solidFill>
+                  <a:srgbClr val="1F2C56"/>
+                </a:solidFill>
+                <a:latin typeface="Arial"/>
+              </a:rPr>
+              <a:t>Drei Gegenmittel gegen zerfasertes Arbeiten</a:t>
+            </a:r>
+          </a:p>
+        </p:txBody>
+      </p:sp>
+      <p:sp>
+        <p:nvSpPr>
+          <p:cNvPr id="6" name="Rectangle 5"/>
+          <p:cNvSpPr/>
+          <p:nvPr/>
+        </p:nvSpPr>
+        <p:spPr>
+          <a:xfrm>
+            <a:off x="685800" y="1143000"/>
+            <a:ext cx="10817352" cy="25400"/>
+          </a:xfrm>
+          <a:prstGeom prst="rect">
+            <a:avLst/>
+          </a:prstGeom>
+          <a:solidFill>
+            <a:srgbClr val="D9C089"/>
+          </a:solidFill>
+          <a:ln>
+            <a:noFill/>
+          </a:ln>
+        </p:spPr>
+        <p:style>
+          <a:lnRef idx="1">
+            <a:schemeClr val="accent1"/>
+          </a:lnRef>
+          <a:fillRef idx="3">
+            <a:schemeClr val="accent1"/>
+          </a:fillRef>
+          <a:effectRef idx="2">
+            <a:schemeClr val="accent1"/>
+          </a:effectRef>
+          <a:fontRef idx="minor">
+            <a:schemeClr val="lt1"/>
+          </a:fontRef>
+        </p:style>
+        <p:txBody>
+          <a:bodyPr rtlCol="0" anchor="ctr"/>
+          <a:lstStyle/>
+          <a:p>
+            <a:pPr algn="ctr"/>
+          </a:p>
+        </p:txBody>
+      </p:sp>
+      <p:pic>
+        <p:nvPicPr>
+          <p:cNvPr id="7" name="Picture 6" descr="image.png"/>
+          <p:cNvPicPr>
+            <a:picLocks noChangeAspect="1"/>
+          </p:cNvPicPr>
+          <p:nvPr/>
+        </p:nvPicPr>
+        <p:blipFill>
+          <a:blip r:embed="rId2"/>
+          <a:stretch>
+            <a:fillRect/>
+          </a:stretch>
+        </p:blipFill>
+        <p:spPr>
+          <a:xfrm>
+            <a:off x="2009463" y="1325880"/>
+            <a:ext cx="8170026" cy="4937760"/>
+          </a:xfrm>
+          <a:prstGeom prst="rect">
+            <a:avLst/>
+          </a:prstGeom>
+        </p:spPr>
+      </p:pic>
+      <p:sp>
+        <p:nvSpPr>
+          <p:cNvPr id="8" name="Rectangle 7"/>
+          <p:cNvSpPr/>
+          <p:nvPr/>
+        </p:nvSpPr>
+        <p:spPr>
+          <a:xfrm>
+            <a:off x="0" y="6510528"/>
+            <a:ext cx="12188952" cy="347472"/>
+          </a:xfrm>
+          <a:prstGeom prst="rect">
+            <a:avLst/>
+          </a:prstGeom>
+          <a:solidFill>
+            <a:srgbClr val="0A1937"/>
+          </a:solidFill>
+          <a:ln>
+            <a:noFill/>
+          </a:ln>
+        </p:spPr>
+        <p:style>
+          <a:lnRef idx="1">
+            <a:schemeClr val="accent1"/>
+          </a:lnRef>
+          <a:fillRef idx="3">
+            <a:schemeClr val="accent1"/>
+          </a:fillRef>
+          <a:effectRef idx="2">
+            <a:schemeClr val="accent1"/>
+          </a:effectRef>
+          <a:fontRef idx="minor">
+            <a:schemeClr val="lt1"/>
+          </a:fontRef>
+        </p:style>
+        <p:txBody>
+          <a:bodyPr rtlCol="0" anchor="ctr"/>
+          <a:lstStyle/>
+          <a:p>
+            <a:pPr algn="ctr"/>
+          </a:p>
+        </p:txBody>
+      </p:sp>
+      <p:sp>
+        <p:nvSpPr>
+          <p:cNvPr id="9" name="TextBox 8"/>
+          <p:cNvSpPr txBox="1"/>
+          <p:nvPr/>
+        </p:nvSpPr>
+        <p:spPr>
+          <a:xfrm>
+            <a:off x="685800" y="6583680"/>
+            <a:ext cx="6490411" cy="256032"/>
+          </a:xfrm>
+          <a:prstGeom prst="rect">
+            <a:avLst/>
+          </a:prstGeom>
+          <a:noFill/>
+        </p:spPr>
+        <p:txBody>
+          <a:bodyPr wrap="none">
+            <a:spAutoFit/>
+          </a:bodyPr>
+          <a:lstStyle/>
+          <a:p>
+            <a:pPr algn="l"/>
+            <a:r>
+              <a:rPr sz="700">
+                <a:solidFill>
+                  <a:srgbClr val="A0B4D2"/>
+                </a:solidFill>
+                <a:latin typeface="Consolas"/>
+              </a:rPr>
+              <a:t>FKB Campus  ·  VA08</a:t>
+            </a:r>
+          </a:p>
+        </p:txBody>
+      </p:sp>
+      <p:sp>
+        <p:nvSpPr>
+          <p:cNvPr id="10" name="TextBox 9"/>
+          <p:cNvSpPr txBox="1"/>
+          <p:nvPr/>
+        </p:nvSpPr>
+        <p:spPr>
+          <a:xfrm>
+            <a:off x="7176211" y="6583680"/>
+            <a:ext cx="4326940" cy="256032"/>
+          </a:xfrm>
+          <a:prstGeom prst="rect">
+            <a:avLst/>
+          </a:prstGeom>
+          <a:noFill/>
+        </p:spPr>
+        <p:txBody>
+          <a:bodyPr wrap="none">
+            <a:spAutoFit/>
+          </a:bodyPr>
+          <a:lstStyle/>
+          <a:p>
+            <a:pPr algn="r"/>
+            <a:r>
+              <a:rPr sz="700">
+                <a:solidFill>
+                  <a:srgbClr val="A0B4D2"/>
+                </a:solidFill>
+                <a:latin typeface="Consolas"/>
+              </a:rPr>
+              <a:t>Schaubild</a:t>
+            </a:r>
+          </a:p>
+        </p:txBody>
+      </p:sp>
+    </p:spTree>
+  </p:cSld>
+  <p:clrMapOvr>
+    <a:masterClrMapping/>
+  </p:clrMapOvr>
+</p:sld>
+</file>
+
+<file path=ppt/slides/slide11.xml><?xml version="1.0" encoding="utf-8"?>
+<p:sld xmlns:a="http://schemas.openxmlformats.org/drawingml/2006/main" xmlns:p="http://schemas.openxmlformats.org/presentationml/2006/main" xmlns:r="http://schemas.openxmlformats.org/officeDocument/2006/relationships">
+  <p:cSld>
+    <p:spTree>
+      <p:nvGrpSpPr>
+        <p:cNvPr id="1" name=""/>
+        <p:cNvGrpSpPr/>
+        <p:nvPr/>
+      </p:nvGrpSpPr>
+      <p:grpSpPr/>
+      <p:sp>
+        <p:nvSpPr>
+          <p:cNvPr id="2" name="Rectangle 1"/>
+          <p:cNvSpPr/>
+          <p:nvPr/>
+        </p:nvSpPr>
+        <p:spPr>
+          <a:xfrm>
+            <a:off x="0" y="0"/>
+            <a:ext cx="12188952" cy="6858000"/>
+          </a:xfrm>
+          <a:prstGeom prst="rect">
+            <a:avLst/>
+          </a:prstGeom>
+          <a:solidFill>
+            <a:srgbClr val="1F2C56"/>
+          </a:solidFill>
+          <a:ln>
+            <a:noFill/>
+          </a:ln>
+        </p:spPr>
+        <p:style>
+          <a:lnRef idx="1">
+            <a:schemeClr val="accent1"/>
+          </a:lnRef>
+          <a:fillRef idx="3">
+            <a:schemeClr val="accent1"/>
+          </a:fillRef>
+          <a:effectRef idx="2">
+            <a:schemeClr val="accent1"/>
+          </a:effectRef>
+          <a:fontRef idx="minor">
+            <a:schemeClr val="lt1"/>
+          </a:fontRef>
+        </p:style>
+        <p:txBody>
+          <a:bodyPr rtlCol="0" anchor="ctr"/>
+          <a:lstStyle/>
+          <a:p>
+            <a:pPr algn="ctr"/>
+          </a:p>
+        </p:txBody>
+      </p:sp>
+      <p:sp>
+        <p:nvSpPr>
+          <p:cNvPr id="3" name="TextBox 2"/>
+          <p:cNvSpPr txBox="1"/>
+          <p:nvPr/>
+        </p:nvSpPr>
+        <p:spPr>
+          <a:xfrm>
+            <a:off x="685800" y="2377440"/>
+            <a:ext cx="10817352" cy="365760"/>
+          </a:xfrm>
+          <a:prstGeom prst="rect">
+            <a:avLst/>
+          </a:prstGeom>
+          <a:noFill/>
+        </p:spPr>
+        <p:txBody>
+          <a:bodyPr wrap="none">
+            <a:spAutoFit/>
+          </a:bodyPr>
+          <a:lstStyle/>
+          <a:p>
+            <a:pPr algn="l"/>
+            <a:r>
+              <a:rPr sz="1200">
+                <a:solidFill>
+                  <a:srgbClr val="D9C089"/>
+                </a:solidFill>
+                <a:latin typeface="Consolas"/>
+              </a:rPr>
+              <a:t>00:30–01:20</a:t>
+            </a:r>
+          </a:p>
+        </p:txBody>
+      </p:sp>
+      <p:sp>
+        <p:nvSpPr>
+          <p:cNvPr id="4" name="Rectangle 3"/>
+          <p:cNvSpPr/>
+          <p:nvPr/>
+        </p:nvSpPr>
+        <p:spPr>
+          <a:xfrm>
+            <a:off x="685800" y="2788920"/>
+            <a:ext cx="548640" cy="38100"/>
+          </a:xfrm>
+          <a:prstGeom prst="rect">
+            <a:avLst/>
+          </a:prstGeom>
+          <a:solidFill>
+            <a:srgbClr val="D9C089"/>
+          </a:solidFill>
+          <a:ln>
+            <a:noFill/>
+          </a:ln>
+        </p:spPr>
+        <p:style>
+          <a:lnRef idx="1">
+            <a:schemeClr val="accent1"/>
+          </a:lnRef>
+          <a:fillRef idx="3">
+            <a:schemeClr val="accent1"/>
+          </a:fillRef>
+          <a:effectRef idx="2">
+            <a:schemeClr val="accent1"/>
+          </a:effectRef>
+          <a:fontRef idx="minor">
+            <a:schemeClr val="lt1"/>
+          </a:fontRef>
+        </p:style>
+        <p:txBody>
+          <a:bodyPr rtlCol="0" anchor="ctr"/>
+          <a:lstStyle/>
+          <a:p>
+            <a:pPr algn="ctr"/>
+          </a:p>
+        </p:txBody>
+      </p:sp>
+      <p:sp>
+        <p:nvSpPr>
+          <p:cNvPr id="5" name="TextBox 4"/>
+          <p:cNvSpPr txBox="1"/>
+          <p:nvPr/>
+        </p:nvSpPr>
+        <p:spPr>
+          <a:xfrm>
+            <a:off x="685800" y="3017520"/>
+            <a:ext cx="10817352" cy="1463040"/>
+          </a:xfrm>
+          <a:prstGeom prst="rect">
+            <a:avLst/>
+          </a:prstGeom>
+          <a:noFill/>
+        </p:spPr>
+        <p:txBody>
+          <a:bodyPr wrap="square">
+            <a:spAutoFit/>
+          </a:bodyPr>
+          <a:lstStyle/>
+          <a:p>
+            <a:pPr algn="l"/>
+            <a:r>
+              <a:rPr sz="4000" b="1" i="0">
+                <a:solidFill>
+                  <a:srgbClr val="FFFFFF"/>
+                </a:solidFill>
+                <a:latin typeface="Arial"/>
+              </a:rPr>
+              <a:t>Fallübergabe &amp; Fallarbeit</a:t>
+            </a:r>
+          </a:p>
+        </p:txBody>
+      </p:sp>
+      <p:sp>
+        <p:nvSpPr>
+          <p:cNvPr id="6" name="TextBox 5"/>
+          <p:cNvSpPr txBox="1"/>
+          <p:nvPr/>
+        </p:nvSpPr>
+        <p:spPr>
+          <a:xfrm>
+            <a:off x="685800" y="4480560"/>
+            <a:ext cx="8653881" cy="1280160"/>
+          </a:xfrm>
+          <a:prstGeom prst="rect">
+            <a:avLst/>
+          </a:prstGeom>
+          <a:noFill/>
+        </p:spPr>
+        <p:txBody>
+          <a:bodyPr wrap="square">
+            <a:spAutoFit/>
+          </a:bodyPr>
+          <a:lstStyle/>
+          <a:p>
+            <a:pPr algn="l"/>
+            <a:r>
+              <a:rPr sz="1600" b="0" i="0">
+                <a:solidFill>
+                  <a:srgbClr val="C8D2E6"/>
+                </a:solidFill>
+                <a:latin typeface="Arial"/>
+              </a:rPr>
+              <a:t>Ein Montagmorgen mit fünf gleichzeitigen Aufgaben – bringen Sie Ordnung hinein.</a:t>
+            </a:r>
+          </a:p>
+        </p:txBody>
+      </p:sp>
+      <p:sp>
+        <p:nvSpPr>
+          <p:cNvPr id="7" name="TextBox 6"/>
+          <p:cNvSpPr txBox="1"/>
+          <p:nvPr/>
+        </p:nvSpPr>
+        <p:spPr>
+          <a:xfrm>
+            <a:off x="685800" y="6355080"/>
+            <a:ext cx="10817352" cy="274320"/>
+          </a:xfrm>
+          <a:prstGeom prst="rect">
+            <a:avLst/>
+          </a:prstGeom>
+          <a:noFill/>
+        </p:spPr>
+        <p:txBody>
+          <a:bodyPr wrap="none">
+            <a:spAutoFit/>
+          </a:bodyPr>
+          <a:lstStyle/>
+          <a:p>
+            <a:pPr algn="l"/>
+            <a:r>
+              <a:rPr sz="700">
+                <a:solidFill>
+                  <a:srgbClr val="8CA0C3"/>
+                </a:solidFill>
+                <a:latin typeface="Consolas"/>
+              </a:rPr>
+              <a:t>FKB Campus  ·  VA08</a:t>
+            </a:r>
+          </a:p>
+        </p:txBody>
+      </p:sp>
+    </p:spTree>
+  </p:cSld>
+  <p:clrMapOvr>
+    <a:masterClrMapping/>
+  </p:clrMapOvr>
+</p:sld>
+</file>
+
+<file path=ppt/slides/slide12.xml><?xml version="1.0" encoding="utf-8"?>
+<p:sld xmlns:a="http://schemas.openxmlformats.org/drawingml/2006/main" xmlns:p="http://schemas.openxmlformats.org/presentationml/2006/main" xmlns:r="http://schemas.openxmlformats.org/officeDocument/2006/relationships">
+  <p:cSld>
+    <p:spTree>
+      <p:nvGrpSpPr>
+        <p:cNvPr id="1" name=""/>
+        <p:cNvGrpSpPr/>
+        <p:nvPr/>
+      </p:nvGrpSpPr>
+      <p:grpSpPr/>
+      <p:sp>
+        <p:nvSpPr>
+          <p:cNvPr id="2" name="Rectangle 1"/>
+          <p:cNvSpPr/>
+          <p:nvPr/>
+        </p:nvSpPr>
+        <p:spPr>
+          <a:xfrm>
+            <a:off x="0" y="0"/>
+            <a:ext cx="12188952" cy="6858000"/>
+          </a:xfrm>
+          <a:prstGeom prst="rect">
+            <a:avLst/>
+          </a:prstGeom>
+          <a:solidFill>
+            <a:srgbClr val="EDEDF3"/>
+          </a:solidFill>
+          <a:ln>
+            <a:noFill/>
+          </a:ln>
+        </p:spPr>
+        <p:style>
+          <a:lnRef idx="1">
+            <a:schemeClr val="accent1"/>
+          </a:lnRef>
+          <a:fillRef idx="3">
+            <a:schemeClr val="accent1"/>
+          </a:fillRef>
+          <a:effectRef idx="2">
+            <a:schemeClr val="accent1"/>
+          </a:effectRef>
+          <a:fontRef idx="minor">
+            <a:schemeClr val="lt1"/>
+          </a:fontRef>
+        </p:style>
+        <p:txBody>
+          <a:bodyPr rtlCol="0" anchor="ctr"/>
+          <a:lstStyle/>
+          <a:p>
+            <a:pPr algn="ctr"/>
+          </a:p>
+        </p:txBody>
+      </p:sp>
+      <p:sp>
+        <p:nvSpPr>
+          <p:cNvPr id="3" name="Rectangle 2"/>
+          <p:cNvSpPr/>
+          <p:nvPr/>
+        </p:nvSpPr>
+        <p:spPr>
+          <a:xfrm>
+            <a:off x="0" y="0"/>
+            <a:ext cx="12188952" cy="50292"/>
+          </a:xfrm>
+          <a:prstGeom prst="rect">
+            <a:avLst/>
+          </a:prstGeom>
+          <a:solidFill>
+            <a:srgbClr val="1F2C56"/>
+          </a:solidFill>
+          <a:ln>
+            <a:noFill/>
+          </a:ln>
+        </p:spPr>
+        <p:style>
+          <a:lnRef idx="1">
+            <a:schemeClr val="accent1"/>
+          </a:lnRef>
+          <a:fillRef idx="3">
+            <a:schemeClr val="accent1"/>
+          </a:fillRef>
+          <a:effectRef idx="2">
+            <a:schemeClr val="accent1"/>
+          </a:effectRef>
+          <a:fontRef idx="minor">
+            <a:schemeClr val="lt1"/>
+          </a:fontRef>
+        </p:style>
+        <p:txBody>
+          <a:bodyPr rtlCol="0" anchor="ctr"/>
+          <a:lstStyle/>
+          <a:p>
+            <a:pPr algn="ctr"/>
+          </a:p>
+        </p:txBody>
+      </p:sp>
+      <p:sp>
+        <p:nvSpPr>
+          <p:cNvPr id="4" name="TextBox 3"/>
+          <p:cNvSpPr txBox="1"/>
+          <p:nvPr/>
+        </p:nvSpPr>
+        <p:spPr>
+          <a:xfrm>
+            <a:off x="685800" y="109728"/>
+            <a:ext cx="10817352" cy="228600"/>
+          </a:xfrm>
+          <a:prstGeom prst="rect">
+            <a:avLst/>
+          </a:prstGeom>
+          <a:noFill/>
+        </p:spPr>
+        <p:txBody>
+          <a:bodyPr wrap="none">
+            <a:spAutoFit/>
+          </a:bodyPr>
+          <a:lstStyle/>
+          <a:p>
+            <a:pPr algn="l"/>
+            <a:r>
+              <a:rPr sz="750">
+                <a:solidFill>
+                  <a:srgbClr val="78808C"/>
+                </a:solidFill>
+                <a:latin typeface="Consolas"/>
+              </a:rPr>
+              <a:t>VA08  ·  INHALT</a:t>
+            </a:r>
+          </a:p>
+        </p:txBody>
+      </p:sp>
+      <p:sp>
+        <p:nvSpPr>
+          <p:cNvPr id="5" name="Rectangle 4"/>
+          <p:cNvSpPr/>
+          <p:nvPr/>
+        </p:nvSpPr>
+        <p:spPr>
+          <a:xfrm>
+            <a:off x="0" y="1234440"/>
+            <a:ext cx="12188952" cy="12700"/>
+          </a:xfrm>
+          <a:prstGeom prst="rect">
+            <a:avLst/>
+          </a:prstGeom>
+          <a:solidFill>
+            <a:srgbClr val="D8DFE4"/>
+          </a:solidFill>
+          <a:ln>
+            <a:noFill/>
+          </a:ln>
+        </p:spPr>
+        <p:style>
+          <a:lnRef idx="1">
+            <a:schemeClr val="accent1"/>
+          </a:lnRef>
+          <a:fillRef idx="3">
+            <a:schemeClr val="accent1"/>
+          </a:fillRef>
+          <a:effectRef idx="2">
+            <a:schemeClr val="accent1"/>
+          </a:effectRef>
+          <a:fontRef idx="minor">
+            <a:schemeClr val="lt1"/>
+          </a:fontRef>
+        </p:style>
+        <p:txBody>
+          <a:bodyPr rtlCol="0" anchor="ctr"/>
+          <a:lstStyle/>
+          <a:p>
+            <a:pPr algn="ctr"/>
+          </a:p>
+        </p:txBody>
+      </p:sp>
+      <p:sp>
+        <p:nvSpPr>
+          <p:cNvPr id="6" name="Rectangle 5"/>
+          <p:cNvSpPr/>
+          <p:nvPr/>
+        </p:nvSpPr>
+        <p:spPr>
+          <a:xfrm>
+            <a:off x="685800" y="502920"/>
+            <a:ext cx="36576" cy="658368"/>
+          </a:xfrm>
+          <a:prstGeom prst="rect">
+            <a:avLst/>
+          </a:prstGeom>
+          <a:solidFill>
+            <a:srgbClr val="D9C089"/>
+          </a:solidFill>
+          <a:ln>
+            <a:noFill/>
+          </a:ln>
+        </p:spPr>
+        <p:style>
+          <a:lnRef idx="1">
+            <a:schemeClr val="accent1"/>
+          </a:lnRef>
+          <a:fillRef idx="3">
+            <a:schemeClr val="accent1"/>
+          </a:fillRef>
+          <a:effectRef idx="2">
+            <a:schemeClr val="accent1"/>
+          </a:effectRef>
+          <a:fontRef idx="minor">
+            <a:schemeClr val="lt1"/>
+          </a:fontRef>
+        </p:style>
+        <p:txBody>
+          <a:bodyPr rtlCol="0" anchor="ctr"/>
+          <a:lstStyle/>
+          <a:p>
+            <a:pPr algn="ctr"/>
+          </a:p>
+        </p:txBody>
+      </p:sp>
+      <p:sp>
+        <p:nvSpPr>
+          <p:cNvPr id="7" name="TextBox 6"/>
+          <p:cNvSpPr txBox="1"/>
+          <p:nvPr/>
+        </p:nvSpPr>
+        <p:spPr>
+          <a:xfrm>
+            <a:off x="813816" y="502920"/>
+            <a:ext cx="10634472" cy="685800"/>
+          </a:xfrm>
+          <a:prstGeom prst="rect">
+            <a:avLst/>
+          </a:prstGeom>
+          <a:noFill/>
+        </p:spPr>
+        <p:txBody>
+          <a:bodyPr wrap="square">
+            <a:spAutoFit/>
+          </a:bodyPr>
+          <a:lstStyle/>
+          <a:p>
+            <a:pPr algn="l"/>
+            <a:r>
+              <a:rPr sz="2400" b="1" i="0">
+                <a:solidFill>
+                  <a:srgbClr val="1F2C56"/>
+                </a:solidFill>
+                <a:latin typeface="Arial"/>
+              </a:rPr>
+              <a:t>Praxisfall: Ein Montagmorgen im Innendienst</a:t>
+            </a:r>
+          </a:p>
+        </p:txBody>
+      </p:sp>
+      <p:sp>
+        <p:nvSpPr>
+          <p:cNvPr id="8" name="TextBox 7"/>
+          <p:cNvSpPr txBox="1"/>
+          <p:nvPr/>
+        </p:nvSpPr>
+        <p:spPr>
+          <a:xfrm>
+            <a:off x="685800" y="1417320"/>
+            <a:ext cx="10817352" cy="4892040"/>
+          </a:xfrm>
+          <a:prstGeom prst="rect">
+            <a:avLst/>
+          </a:prstGeom>
+          <a:noFill/>
+        </p:spPr>
+        <p:txBody>
+          <a:bodyPr wrap="square">
+            <a:spAutoFit/>
+          </a:bodyPr>
+          <a:lstStyle/>
+          <a:p>
+            <a:pPr>
+              <a:spcBef>
+                <a:spcPts val="1000"/>
+              </a:spcBef>
+              <a:spcAft>
+                <a:spcPts val="200"/>
+              </a:spcAft>
+            </a:pPr>
+            <a:r>
+              <a:rPr sz="800" b="1">
+                <a:solidFill>
+                  <a:srgbClr val="78808C"/>
+                </a:solidFill>
+                <a:latin typeface="Consolas"/>
+              </a:rPr>
+              <a:t>MONTAG, 8:00 UHR – FÜNF DINGE GLEICHZEITIG</a:t>
+            </a:r>
+          </a:p>
+          <a:p>
+            <a:pPr marL="190500" indent="-190500">
+              <a:spcBef>
+                <a:spcPts val="400"/>
+              </a:spcBef>
+              <a:spcAft>
+                <a:spcPts val="200"/>
+              </a:spcAft>
+            </a:pPr>
+            <a:r>
+              <a:rPr sz="1300">
+                <a:solidFill>
+                  <a:srgbClr val="3D5466"/>
+                </a:solidFill>
+                <a:latin typeface="Arial"/>
+              </a:rPr>
+              <a:t>▸  Ein Berater bittet bis 11:00 Uhr um eine Engagementübersicht für einen Mittagstermin.</a:t>
+            </a:r>
+          </a:p>
+          <a:p>
+            <a:pPr marL="190500" indent="-190500">
+              <a:spcBef>
+                <a:spcPts val="400"/>
+              </a:spcBef>
+              <a:spcAft>
+                <a:spcPts val="200"/>
+              </a:spcAft>
+            </a:pPr>
+            <a:r>
+              <a:rPr sz="1300">
+                <a:solidFill>
+                  <a:srgbClr val="3D5466"/>
+                </a:solidFill>
+                <a:latin typeface="Arial"/>
+              </a:rPr>
+              <a:t>▸  Drei Wiedervorlagen sind heute fällig (fehlende BWA, Adressänderung, Sicherheitennachweis).</a:t>
+            </a:r>
+          </a:p>
+          <a:p>
+            <a:pPr marL="190500" indent="-190500">
+              <a:spcBef>
+                <a:spcPts val="400"/>
+              </a:spcBef>
+              <a:spcAft>
+                <a:spcPts val="200"/>
+              </a:spcAft>
+            </a:pPr>
+            <a:r>
+              <a:rPr sz="1300">
+                <a:solidFill>
+                  <a:srgbClr val="3D5466"/>
+                </a:solidFill>
+                <a:latin typeface="Arial"/>
+              </a:rPr>
+              <a:t>▸  Eine Kundin hat eine einfache Frage per Mail (2 Minuten); die Quartals-Datenpflege „könnte man mal machen"; das Telefon klingelt mehrfach.</a:t>
+            </a:r>
+          </a:p>
+          <a:p>
+            <a:pPr>
+              <a:spcBef>
+                <a:spcPts val="1000"/>
+              </a:spcBef>
+              <a:spcAft>
+                <a:spcPts val="200"/>
+              </a:spcAft>
+            </a:pPr>
+            <a:r>
+              <a:rPr sz="800" b="1">
+                <a:solidFill>
+                  <a:srgbClr val="78808C"/>
+                </a:solidFill>
+                <a:latin typeface="Consolas"/>
+              </a:rPr>
+              <a:t>IHRE AUFGABE</a:t>
+            </a:r>
+          </a:p>
+          <a:p>
+            <a:pPr marL="190500" indent="-190500">
+              <a:spcBef>
+                <a:spcPts val="400"/>
+              </a:spcBef>
+              <a:spcAft>
+                <a:spcPts val="200"/>
+              </a:spcAft>
+            </a:pPr>
+            <a:r>
+              <a:rPr sz="1300">
+                <a:solidFill>
+                  <a:srgbClr val="3D5466"/>
+                </a:solidFill>
+                <a:latin typeface="Arial"/>
+              </a:rPr>
+              <a:t>▸  Bringen Sie Ordnung in diesen Morgen – zuerst allein, dann im Vergleich.</a:t>
+            </a:r>
+          </a:p>
+        </p:txBody>
+      </p:sp>
+      <p:sp>
+        <p:nvSpPr>
+          <p:cNvPr id="9" name="Rectangle 8"/>
+          <p:cNvSpPr/>
+          <p:nvPr/>
+        </p:nvSpPr>
+        <p:spPr>
+          <a:xfrm>
+            <a:off x="0" y="6510528"/>
+            <a:ext cx="12188952" cy="347472"/>
+          </a:xfrm>
+          <a:prstGeom prst="rect">
+            <a:avLst/>
+          </a:prstGeom>
+          <a:solidFill>
+            <a:srgbClr val="0A1937"/>
+          </a:solidFill>
+          <a:ln>
+            <a:noFill/>
+          </a:ln>
+        </p:spPr>
+        <p:style>
+          <a:lnRef idx="1">
+            <a:schemeClr val="accent1"/>
+          </a:lnRef>
+          <a:fillRef idx="3">
+            <a:schemeClr val="accent1"/>
+          </a:fillRef>
+          <a:effectRef idx="2">
+            <a:schemeClr val="accent1"/>
+          </a:effectRef>
+          <a:fontRef idx="minor">
+            <a:schemeClr val="lt1"/>
+          </a:fontRef>
+        </p:style>
+        <p:txBody>
+          <a:bodyPr rtlCol="0" anchor="ctr"/>
+          <a:lstStyle/>
+          <a:p>
+            <a:pPr algn="ctr"/>
+          </a:p>
+        </p:txBody>
+      </p:sp>
+      <p:sp>
+        <p:nvSpPr>
+          <p:cNvPr id="10" name="TextBox 9"/>
+          <p:cNvSpPr txBox="1"/>
+          <p:nvPr/>
+        </p:nvSpPr>
+        <p:spPr>
+          <a:xfrm>
+            <a:off x="685800" y="6583680"/>
+            <a:ext cx="6490411" cy="256032"/>
+          </a:xfrm>
+          <a:prstGeom prst="rect">
+            <a:avLst/>
+          </a:prstGeom>
+          <a:noFill/>
+        </p:spPr>
+        <p:txBody>
+          <a:bodyPr wrap="none">
+            <a:spAutoFit/>
+          </a:bodyPr>
+          <a:lstStyle/>
+          <a:p>
+            <a:pPr algn="l"/>
+            <a:r>
+              <a:rPr sz="700">
+                <a:solidFill>
+                  <a:srgbClr val="A0B4D2"/>
+                </a:solidFill>
+                <a:latin typeface="Consolas"/>
+              </a:rPr>
+              <a:t>FKB Campus  ·  VA08</a:t>
+            </a:r>
+          </a:p>
+        </p:txBody>
+      </p:sp>
+    </p:spTree>
+  </p:cSld>
+  <p:clrMapOvr>
+    <a:masterClrMapping/>
+  </p:clrMapOvr>
+</p:sld>
+</file>
+
+<file path=ppt/slides/slide13.xml><?xml version="1.0" encoding="utf-8"?>
+<p:sld xmlns:a="http://schemas.openxmlformats.org/drawingml/2006/main" xmlns:p="http://schemas.openxmlformats.org/presentationml/2006/main" xmlns:r="http://schemas.openxmlformats.org/officeDocument/2006/relationships">
+  <p:cSld>
+    <p:spTree>
+      <p:nvGrpSpPr>
+        <p:cNvPr id="1" name=""/>
+        <p:cNvGrpSpPr/>
+        <p:nvPr/>
+      </p:nvGrpSpPr>
+      <p:grpSpPr/>
+      <p:sp>
+        <p:nvSpPr>
+          <p:cNvPr id="2" name="Rectangle 1"/>
+          <p:cNvSpPr/>
+          <p:nvPr/>
+        </p:nvSpPr>
+        <p:spPr>
+          <a:xfrm>
+            <a:off x="0" y="0"/>
+            <a:ext cx="12188952" cy="6858000"/>
+          </a:xfrm>
+          <a:prstGeom prst="rect">
+            <a:avLst/>
+          </a:prstGeom>
+          <a:solidFill>
+            <a:srgbClr val="EDEDF3"/>
+          </a:solidFill>
+          <a:ln>
+            <a:noFill/>
+          </a:ln>
+        </p:spPr>
+        <p:style>
+          <a:lnRef idx="1">
+            <a:schemeClr val="accent1"/>
+          </a:lnRef>
+          <a:fillRef idx="3">
+            <a:schemeClr val="accent1"/>
+          </a:fillRef>
+          <a:effectRef idx="2">
+            <a:schemeClr val="accent1"/>
+          </a:effectRef>
+          <a:fontRef idx="minor">
+            <a:schemeClr val="lt1"/>
+          </a:fontRef>
+        </p:style>
+        <p:txBody>
+          <a:bodyPr rtlCol="0" anchor="ctr"/>
+          <a:lstStyle/>
+          <a:p>
+            <a:pPr algn="ctr"/>
+          </a:p>
+        </p:txBody>
+      </p:sp>
+      <p:sp>
+        <p:nvSpPr>
+          <p:cNvPr id="3" name="Rectangle 2"/>
+          <p:cNvSpPr/>
+          <p:nvPr/>
+        </p:nvSpPr>
+        <p:spPr>
+          <a:xfrm>
+            <a:off x="0" y="0"/>
+            <a:ext cx="12188952" cy="50292"/>
+          </a:xfrm>
+          <a:prstGeom prst="rect">
+            <a:avLst/>
+          </a:prstGeom>
+          <a:solidFill>
+            <a:srgbClr val="1F2C56"/>
+          </a:solidFill>
+          <a:ln>
+            <a:noFill/>
+          </a:ln>
+        </p:spPr>
+        <p:style>
+          <a:lnRef idx="1">
+            <a:schemeClr val="accent1"/>
+          </a:lnRef>
+          <a:fillRef idx="3">
+            <a:schemeClr val="accent1"/>
+          </a:fillRef>
+          <a:effectRef idx="2">
+            <a:schemeClr val="accent1"/>
+          </a:effectRef>
+          <a:fontRef idx="minor">
+            <a:schemeClr val="lt1"/>
+          </a:fontRef>
+        </p:style>
+        <p:txBody>
+          <a:bodyPr rtlCol="0" anchor="ctr"/>
+          <a:lstStyle/>
+          <a:p>
+            <a:pPr algn="ctr"/>
+          </a:p>
+        </p:txBody>
+      </p:sp>
+      <p:sp>
+        <p:nvSpPr>
+          <p:cNvPr id="4" name="TextBox 3"/>
+          <p:cNvSpPr txBox="1"/>
+          <p:nvPr/>
+        </p:nvSpPr>
+        <p:spPr>
+          <a:xfrm>
+            <a:off x="685800" y="109728"/>
+            <a:ext cx="10817352" cy="228600"/>
+          </a:xfrm>
+          <a:prstGeom prst="rect">
+            <a:avLst/>
+          </a:prstGeom>
+          <a:noFill/>
+        </p:spPr>
+        <p:txBody>
+          <a:bodyPr wrap="none">
+            <a:spAutoFit/>
+          </a:bodyPr>
+          <a:lstStyle/>
+          <a:p>
+            <a:pPr algn="l"/>
+            <a:r>
+              <a:rPr sz="750">
+                <a:solidFill>
+                  <a:srgbClr val="78808C"/>
+                </a:solidFill>
+                <a:latin typeface="Consolas"/>
+              </a:rPr>
+              <a:t>VA08  ·  INHALT</a:t>
+            </a:r>
+          </a:p>
+        </p:txBody>
+      </p:sp>
+      <p:sp>
+        <p:nvSpPr>
+          <p:cNvPr id="5" name="Rectangle 4"/>
+          <p:cNvSpPr/>
+          <p:nvPr/>
+        </p:nvSpPr>
+        <p:spPr>
+          <a:xfrm>
+            <a:off x="0" y="1234440"/>
+            <a:ext cx="12188952" cy="12700"/>
+          </a:xfrm>
+          <a:prstGeom prst="rect">
+            <a:avLst/>
+          </a:prstGeom>
+          <a:solidFill>
+            <a:srgbClr val="D8DFE4"/>
+          </a:solidFill>
+          <a:ln>
+            <a:noFill/>
+          </a:ln>
+        </p:spPr>
+        <p:style>
+          <a:lnRef idx="1">
+            <a:schemeClr val="accent1"/>
+          </a:lnRef>
+          <a:fillRef idx="3">
+            <a:schemeClr val="accent1"/>
+          </a:fillRef>
+          <a:effectRef idx="2">
+            <a:schemeClr val="accent1"/>
+          </a:effectRef>
+          <a:fontRef idx="minor">
+            <a:schemeClr val="lt1"/>
+          </a:fontRef>
+        </p:style>
+        <p:txBody>
+          <a:bodyPr rtlCol="0" anchor="ctr"/>
+          <a:lstStyle/>
+          <a:p>
+            <a:pPr algn="ctr"/>
+          </a:p>
+        </p:txBody>
+      </p:sp>
+      <p:sp>
+        <p:nvSpPr>
+          <p:cNvPr id="6" name="Rectangle 5"/>
+          <p:cNvSpPr/>
+          <p:nvPr/>
+        </p:nvSpPr>
+        <p:spPr>
+          <a:xfrm>
+            <a:off x="685800" y="502920"/>
+            <a:ext cx="36576" cy="658368"/>
+          </a:xfrm>
+          <a:prstGeom prst="rect">
+            <a:avLst/>
+          </a:prstGeom>
+          <a:solidFill>
+            <a:srgbClr val="D9C089"/>
+          </a:solidFill>
+          <a:ln>
+            <a:noFill/>
+          </a:ln>
+        </p:spPr>
+        <p:style>
+          <a:lnRef idx="1">
+            <a:schemeClr val="accent1"/>
+          </a:lnRef>
+          <a:fillRef idx="3">
+            <a:schemeClr val="accent1"/>
+          </a:fillRef>
+          <a:effectRef idx="2">
+            <a:schemeClr val="accent1"/>
+          </a:effectRef>
+          <a:fontRef idx="minor">
+            <a:schemeClr val="lt1"/>
+          </a:fontRef>
+        </p:style>
+        <p:txBody>
+          <a:bodyPr rtlCol="0" anchor="ctr"/>
+          <a:lstStyle/>
+          <a:p>
+            <a:pPr algn="ctr"/>
+          </a:p>
+        </p:txBody>
+      </p:sp>
+      <p:sp>
+        <p:nvSpPr>
+          <p:cNvPr id="7" name="TextBox 6"/>
+          <p:cNvSpPr txBox="1"/>
+          <p:nvPr/>
+        </p:nvSpPr>
+        <p:spPr>
+          <a:xfrm>
+            <a:off x="813816" y="502920"/>
+            <a:ext cx="10634472" cy="685800"/>
+          </a:xfrm>
+          <a:prstGeom prst="rect">
+            <a:avLst/>
+          </a:prstGeom>
+          <a:noFill/>
+        </p:spPr>
+        <p:txBody>
+          <a:bodyPr wrap="square">
+            <a:spAutoFit/>
+          </a:bodyPr>
+          <a:lstStyle/>
+          <a:p>
+            <a:pPr algn="l"/>
+            <a:r>
+              <a:rPr sz="2400" b="1" i="0">
+                <a:solidFill>
+                  <a:srgbClr val="1F2C56"/>
+                </a:solidFill>
+                <a:latin typeface="Arial"/>
+              </a:rPr>
+              <a:t>Handlungsempfehlung: erst ordnen, dann arbeiten</a:t>
+            </a:r>
+          </a:p>
+        </p:txBody>
+      </p:sp>
+      <p:sp>
+        <p:nvSpPr>
+          <p:cNvPr id="8" name="TextBox 7"/>
+          <p:cNvSpPr txBox="1"/>
+          <p:nvPr/>
+        </p:nvSpPr>
+        <p:spPr>
+          <a:xfrm>
+            <a:off x="685800" y="1417320"/>
+            <a:ext cx="10817352" cy="4892040"/>
+          </a:xfrm>
+          <a:prstGeom prst="rect">
+            <a:avLst/>
+          </a:prstGeom>
+          <a:noFill/>
+        </p:spPr>
+        <p:txBody>
+          <a:bodyPr wrap="square" anchor="ctr">
+            <a:spAutoFit/>
+          </a:bodyPr>
+          <a:lstStyle/>
+          <a:p>
+            <a:pPr marL="177800" indent="-177800">
+              <a:spcBef>
+                <a:spcPts val="600"/>
+              </a:spcBef>
+              <a:spcAft>
+                <a:spcPts val="200"/>
+              </a:spcAft>
+            </a:pPr>
+            <a:r>
+              <a:rPr sz="1200" i="1">
+                <a:solidFill>
+                  <a:srgbClr val="3D5466"/>
+                </a:solidFill>
+                <a:latin typeface="Arial"/>
+              </a:rPr>
+              <a:t>→  Wenn mehrere Aufgaben gleichzeitig anliegen — dann zuerst nach Wichtigkeit und Dringlichkeit einordnen, bevor Sie beginnen.</a:t>
+            </a:r>
+          </a:p>
+          <a:p>
+            <a:pPr marL="177800" indent="-177800">
+              <a:spcBef>
+                <a:spcPts val="600"/>
+              </a:spcBef>
+              <a:spcAft>
+                <a:spcPts val="200"/>
+              </a:spcAft>
+            </a:pPr>
+            <a:r>
+              <a:rPr sz="1200" i="1">
+                <a:solidFill>
+                  <a:srgbClr val="3D5466"/>
+                </a:solidFill>
+                <a:latin typeface="Arial"/>
+              </a:rPr>
+              <a:t>→  Wenn eine Aufgabe in unter zwei Minuten erledigt ist — dann sofort erledigen, statt sie auf die Liste zu setzen.</a:t>
+            </a:r>
+          </a:p>
+          <a:p>
+            <a:pPr marL="177800" indent="-177800">
+              <a:spcBef>
+                <a:spcPts val="600"/>
+              </a:spcBef>
+              <a:spcAft>
+                <a:spcPts val="200"/>
+              </a:spcAft>
+            </a:pPr>
+            <a:r>
+              <a:rPr sz="1200" i="1">
+                <a:solidFill>
+                  <a:srgbClr val="3D5466"/>
+                </a:solidFill>
+                <a:latin typeface="Arial"/>
+              </a:rPr>
+              <a:t>→  Wenn Sie einen störungsfreien Block einführen möchten — dann die Teamleitung einmalig konkret ansprechen (Telefonvertretung für 45 Minuten).</a:t>
+            </a:r>
+          </a:p>
+        </p:txBody>
+      </p:sp>
+      <p:sp>
+        <p:nvSpPr>
+          <p:cNvPr id="9" name="Rectangle 8"/>
+          <p:cNvSpPr/>
+          <p:nvPr/>
+        </p:nvSpPr>
+        <p:spPr>
+          <a:xfrm>
+            <a:off x="0" y="6510528"/>
+            <a:ext cx="12188952" cy="347472"/>
+          </a:xfrm>
+          <a:prstGeom prst="rect">
+            <a:avLst/>
+          </a:prstGeom>
+          <a:solidFill>
+            <a:srgbClr val="0A1937"/>
+          </a:solidFill>
+          <a:ln>
+            <a:noFill/>
+          </a:ln>
+        </p:spPr>
+        <p:style>
+          <a:lnRef idx="1">
+            <a:schemeClr val="accent1"/>
+          </a:lnRef>
+          <a:fillRef idx="3">
+            <a:schemeClr val="accent1"/>
+          </a:fillRef>
+          <a:effectRef idx="2">
+            <a:schemeClr val="accent1"/>
+          </a:effectRef>
+          <a:fontRef idx="minor">
+            <a:schemeClr val="lt1"/>
+          </a:fontRef>
+        </p:style>
+        <p:txBody>
+          <a:bodyPr rtlCol="0" anchor="ctr"/>
+          <a:lstStyle/>
+          <a:p>
+            <a:pPr algn="ctr"/>
+          </a:p>
+        </p:txBody>
+      </p:sp>
+      <p:sp>
+        <p:nvSpPr>
+          <p:cNvPr id="10" name="TextBox 9"/>
+          <p:cNvSpPr txBox="1"/>
+          <p:nvPr/>
+        </p:nvSpPr>
+        <p:spPr>
+          <a:xfrm>
+            <a:off x="685800" y="6583680"/>
+            <a:ext cx="6490411" cy="256032"/>
+          </a:xfrm>
+          <a:prstGeom prst="rect">
+            <a:avLst/>
+          </a:prstGeom>
+          <a:noFill/>
+        </p:spPr>
+        <p:txBody>
+          <a:bodyPr wrap="none">
+            <a:spAutoFit/>
+          </a:bodyPr>
+          <a:lstStyle/>
+          <a:p>
+            <a:pPr algn="l"/>
+            <a:r>
+              <a:rPr sz="700">
+                <a:solidFill>
+                  <a:srgbClr val="A0B4D2"/>
+                </a:solidFill>
+                <a:latin typeface="Consolas"/>
+              </a:rPr>
+              <a:t>FKB Campus  ·  VA08</a:t>
+            </a:r>
+          </a:p>
+        </p:txBody>
+      </p:sp>
+    </p:spTree>
+  </p:cSld>
+  <p:clrMapOvr>
+    <a:masterClrMapping/>
+  </p:clrMapOvr>
+</p:sld>
+</file>
+
+<file path=ppt/slides/slide14.xml><?xml version="1.0" encoding="utf-8"?>
+<p:sld xmlns:a="http://schemas.openxmlformats.org/drawingml/2006/main" xmlns:p="http://schemas.openxmlformats.org/presentationml/2006/main" xmlns:r="http://schemas.openxmlformats.org/officeDocument/2006/relationships">
+  <p:cSld>
+    <p:spTree>
+      <p:nvGrpSpPr>
+        <p:cNvPr id="1" name=""/>
+        <p:cNvGrpSpPr/>
+        <p:nvPr/>
+      </p:nvGrpSpPr>
+      <p:grpSpPr/>
+      <p:sp>
+        <p:nvSpPr>
+          <p:cNvPr id="2" name="Rectangle 1"/>
+          <p:cNvSpPr/>
+          <p:nvPr/>
+        </p:nvSpPr>
+        <p:spPr>
+          <a:xfrm>
+            <a:off x="0" y="0"/>
+            <a:ext cx="12188952" cy="6858000"/>
+          </a:xfrm>
+          <a:prstGeom prst="rect">
+            <a:avLst/>
+          </a:prstGeom>
+          <a:solidFill>
+            <a:srgbClr val="EDEDF3"/>
+          </a:solidFill>
+          <a:ln>
+            <a:noFill/>
+          </a:ln>
+        </p:spPr>
+        <p:style>
+          <a:lnRef idx="1">
+            <a:schemeClr val="accent1"/>
+          </a:lnRef>
+          <a:fillRef idx="3">
+            <a:schemeClr val="accent1"/>
+          </a:fillRef>
+          <a:effectRef idx="2">
+            <a:schemeClr val="accent1"/>
+          </a:effectRef>
+          <a:fontRef idx="minor">
+            <a:schemeClr val="lt1"/>
+          </a:fontRef>
+        </p:style>
+        <p:txBody>
+          <a:bodyPr rtlCol="0" anchor="ctr"/>
+          <a:lstStyle/>
+          <a:p>
+            <a:pPr algn="ctr"/>
+          </a:p>
+        </p:txBody>
+      </p:sp>
+      <p:sp>
+        <p:nvSpPr>
+          <p:cNvPr id="3" name="Rectangle 2"/>
+          <p:cNvSpPr/>
+          <p:nvPr/>
+        </p:nvSpPr>
+        <p:spPr>
+          <a:xfrm>
+            <a:off x="0" y="0"/>
+            <a:ext cx="12188952" cy="50292"/>
+          </a:xfrm>
+          <a:prstGeom prst="rect">
+            <a:avLst/>
+          </a:prstGeom>
+          <a:solidFill>
+            <a:srgbClr val="1F2C56"/>
+          </a:solidFill>
+          <a:ln>
+            <a:noFill/>
+          </a:ln>
+        </p:spPr>
+        <p:style>
+          <a:lnRef idx="1">
+            <a:schemeClr val="accent1"/>
+          </a:lnRef>
+          <a:fillRef idx="3">
+            <a:schemeClr val="accent1"/>
+          </a:fillRef>
+          <a:effectRef idx="2">
+            <a:schemeClr val="accent1"/>
+          </a:effectRef>
+          <a:fontRef idx="minor">
+            <a:schemeClr val="lt1"/>
+          </a:fontRef>
+        </p:style>
+        <p:txBody>
+          <a:bodyPr rtlCol="0" anchor="ctr"/>
+          <a:lstStyle/>
+          <a:p>
+            <a:pPr algn="ctr"/>
+          </a:p>
+        </p:txBody>
+      </p:sp>
+      <p:sp>
+        <p:nvSpPr>
+          <p:cNvPr id="4" name="TextBox 3"/>
+          <p:cNvSpPr txBox="1"/>
+          <p:nvPr/>
+        </p:nvSpPr>
+        <p:spPr>
+          <a:xfrm>
+            <a:off x="685800" y="109728"/>
+            <a:ext cx="10817352" cy="228600"/>
+          </a:xfrm>
+          <a:prstGeom prst="rect">
+            <a:avLst/>
+          </a:prstGeom>
+          <a:noFill/>
+        </p:spPr>
+        <p:txBody>
+          <a:bodyPr wrap="none">
+            <a:spAutoFit/>
+          </a:bodyPr>
+          <a:lstStyle/>
+          <a:p>
+            <a:pPr algn="l"/>
+            <a:r>
+              <a:rPr sz="750">
+                <a:solidFill>
+                  <a:srgbClr val="78808C"/>
+                </a:solidFill>
+                <a:latin typeface="Consolas"/>
+              </a:rPr>
+              <a:t>VA08  ·  ARBEITSBLATT</a:t>
+            </a:r>
+          </a:p>
+        </p:txBody>
+      </p:sp>
+      <p:sp>
+        <p:nvSpPr>
+          <p:cNvPr id="5" name="Rectangle 4"/>
+          <p:cNvSpPr/>
+          <p:nvPr/>
+        </p:nvSpPr>
+        <p:spPr>
+          <a:xfrm>
+            <a:off x="0" y="1234440"/>
+            <a:ext cx="12188952" cy="12700"/>
+          </a:xfrm>
+          <a:prstGeom prst="rect">
+            <a:avLst/>
+          </a:prstGeom>
+          <a:solidFill>
+            <a:srgbClr val="D8DFE4"/>
+          </a:solidFill>
+          <a:ln>
+            <a:noFill/>
+          </a:ln>
+        </p:spPr>
+        <p:style>
+          <a:lnRef idx="1">
+            <a:schemeClr val="accent1"/>
+          </a:lnRef>
+          <a:fillRef idx="3">
+            <a:schemeClr val="accent1"/>
+          </a:fillRef>
+          <a:effectRef idx="2">
+            <a:schemeClr val="accent1"/>
+          </a:effectRef>
+          <a:fontRef idx="minor">
+            <a:schemeClr val="lt1"/>
+          </a:fontRef>
+        </p:style>
+        <p:txBody>
+          <a:bodyPr rtlCol="0" anchor="ctr"/>
+          <a:lstStyle/>
+          <a:p>
+            <a:pPr algn="ctr"/>
+          </a:p>
+        </p:txBody>
+      </p:sp>
+      <p:sp>
+        <p:nvSpPr>
+          <p:cNvPr id="6" name="Rectangle 5"/>
+          <p:cNvSpPr/>
+          <p:nvPr/>
+        </p:nvSpPr>
+        <p:spPr>
+          <a:xfrm>
+            <a:off x="685800" y="502920"/>
+            <a:ext cx="36576" cy="658368"/>
+          </a:xfrm>
+          <a:prstGeom prst="rect">
+            <a:avLst/>
+          </a:prstGeom>
+          <a:solidFill>
+            <a:srgbClr val="D9C089"/>
+          </a:solidFill>
+          <a:ln>
+            <a:noFill/>
+          </a:ln>
+        </p:spPr>
+        <p:style>
+          <a:lnRef idx="1">
+            <a:schemeClr val="accent1"/>
+          </a:lnRef>
+          <a:fillRef idx="3">
+            <a:schemeClr val="accent1"/>
+          </a:fillRef>
+          <a:effectRef idx="2">
+            <a:schemeClr val="accent1"/>
+          </a:effectRef>
+          <a:fontRef idx="minor">
+            <a:schemeClr val="lt1"/>
+          </a:fontRef>
+        </p:style>
+        <p:txBody>
+          <a:bodyPr rtlCol="0" anchor="ctr"/>
+          <a:lstStyle/>
+          <a:p>
+            <a:pPr algn="ctr"/>
+          </a:p>
+        </p:txBody>
+      </p:sp>
+      <p:sp>
+        <p:nvSpPr>
+          <p:cNvPr id="7" name="TextBox 6"/>
+          <p:cNvSpPr txBox="1"/>
+          <p:nvPr/>
+        </p:nvSpPr>
+        <p:spPr>
+          <a:xfrm>
+            <a:off x="813816" y="502920"/>
+            <a:ext cx="10634472" cy="685800"/>
+          </a:xfrm>
+          <a:prstGeom prst="rect">
+            <a:avLst/>
+          </a:prstGeom>
+          <a:noFill/>
+        </p:spPr>
+        <p:txBody>
+          <a:bodyPr wrap="square">
+            <a:spAutoFit/>
+          </a:bodyPr>
+          <a:lstStyle/>
+          <a:p>
+            <a:pPr algn="l"/>
+            <a:r>
+              <a:rPr sz="2400" b="1" i="0">
+                <a:solidFill>
+                  <a:srgbClr val="1F2C56"/>
+                </a:solidFill>
+                <a:latin typeface="Arial"/>
+              </a:rPr>
+              <a:t>Praxisfall bearbeiten: ordnen und steuern</a:t>
+            </a:r>
+          </a:p>
+        </p:txBody>
+      </p:sp>
+      <p:sp>
+        <p:nvSpPr>
+          <p:cNvPr id="8" name="TextBox 7"/>
+          <p:cNvSpPr txBox="1"/>
+          <p:nvPr/>
+        </p:nvSpPr>
+        <p:spPr>
+          <a:xfrm>
+            <a:off x="685800" y="1554480"/>
+            <a:ext cx="10817352" cy="3840480"/>
+          </a:xfrm>
+          <a:prstGeom prst="rect">
+            <a:avLst/>
+          </a:prstGeom>
+          <a:noFill/>
+        </p:spPr>
+        <p:txBody>
+          <a:bodyPr wrap="square">
+            <a:spAutoFit/>
+          </a:bodyPr>
+          <a:lstStyle/>
+          <a:p>
+            <a:pPr marL="190500" indent="-190500">
+              <a:spcBef>
+                <a:spcPts val="400"/>
+              </a:spcBef>
+              <a:spcAft>
+                <a:spcPts val="200"/>
+              </a:spcAft>
+            </a:pPr>
+            <a:r>
+              <a:rPr sz="1400">
+                <a:solidFill>
+                  <a:srgbClr val="3D5466"/>
+                </a:solidFill>
+                <a:latin typeface="Arial"/>
+              </a:rPr>
+              <a:t>▸  Ordnen Sie die fünf Aufgaben in die Eisenhower-Matrix ein (AB-1).</a:t>
+            </a:r>
+          </a:p>
+          <a:p>
+            <a:pPr marL="190500" indent="-190500">
+              <a:spcBef>
+                <a:spcPts val="400"/>
+              </a:spcBef>
+              <a:spcAft>
+                <a:spcPts val="200"/>
+              </a:spcAft>
+            </a:pPr>
+            <a:r>
+              <a:rPr sz="1400">
+                <a:solidFill>
+                  <a:srgbClr val="3D5466"/>
+                </a:solidFill>
+                <a:latin typeface="Arial"/>
+              </a:rPr>
+              <a:t>▸  Bringen Sie sie in eine begründete Bearbeitungsreihenfolge (AB-2).</a:t>
+            </a:r>
+          </a:p>
+          <a:p>
+            <a:pPr marL="190500" indent="-190500">
+              <a:spcBef>
+                <a:spcPts val="400"/>
+              </a:spcBef>
+              <a:spcAft>
+                <a:spcPts val="200"/>
+              </a:spcAft>
+            </a:pPr>
+            <a:r>
+              <a:rPr sz="1400">
+                <a:solidFill>
+                  <a:srgbClr val="3D5466"/>
+                </a:solidFill>
+                <a:latin typeface="Arial"/>
+              </a:rPr>
+              <a:t>▸  Benennen Sie Ihre eigenen Zeitfresser und je eine Gegenmaßnahme (AB-3).</a:t>
+            </a:r>
+          </a:p>
+          <a:p>
+            <a:pPr marL="190500" indent="-190500">
+              <a:spcBef>
+                <a:spcPts val="400"/>
+              </a:spcBef>
+              <a:spcAft>
+                <a:spcPts val="200"/>
+              </a:spcAft>
+            </a:pPr>
+            <a:r>
+              <a:rPr sz="1400">
+                <a:solidFill>
+                  <a:srgbClr val="3D5466"/>
+                </a:solidFill>
+                <a:latin typeface="Arial"/>
+              </a:rPr>
+              <a:t>▸  Entwerfen Sie Ihr Wochensystem: wo, wann, welcher Block? (AB-4) – Karte AB-5 als Werkzeug.</a:t>
+            </a:r>
+          </a:p>
+        </p:txBody>
+      </p:sp>
+      <p:sp>
+        <p:nvSpPr>
+          <p:cNvPr id="9" name="Rectangle 8"/>
+          <p:cNvSpPr/>
+          <p:nvPr/>
+        </p:nvSpPr>
+        <p:spPr>
+          <a:xfrm>
+            <a:off x="685800" y="5486400"/>
+            <a:ext cx="10817352" cy="640080"/>
+          </a:xfrm>
+          <a:prstGeom prst="rect">
+            <a:avLst/>
+          </a:prstGeom>
+          <a:solidFill>
+            <a:srgbClr val="1F2C56"/>
+          </a:solidFill>
+          <a:ln>
+            <a:noFill/>
+          </a:ln>
+        </p:spPr>
+        <p:style>
+          <a:lnRef idx="1">
+            <a:schemeClr val="accent1"/>
+          </a:lnRef>
+          <a:fillRef idx="3">
+            <a:schemeClr val="accent1"/>
+          </a:fillRef>
+          <a:effectRef idx="2">
+            <a:schemeClr val="accent1"/>
+          </a:effectRef>
+          <a:fontRef idx="minor">
+            <a:schemeClr val="lt1"/>
+          </a:fontRef>
+        </p:style>
+        <p:txBody>
+          <a:bodyPr rtlCol="0" anchor="ctr"/>
+          <a:lstStyle/>
+          <a:p>
+            <a:pPr algn="ctr"/>
+          </a:p>
+        </p:txBody>
+      </p:sp>
+      <p:sp>
+        <p:nvSpPr>
+          <p:cNvPr id="10" name="TextBox 9"/>
+          <p:cNvSpPr txBox="1"/>
+          <p:nvPr/>
+        </p:nvSpPr>
+        <p:spPr>
+          <a:xfrm>
+            <a:off x="868680" y="5596128"/>
+            <a:ext cx="10451592" cy="457200"/>
+          </a:xfrm>
+          <a:prstGeom prst="rect">
+            <a:avLst/>
+          </a:prstGeom>
+          <a:noFill/>
+        </p:spPr>
+        <p:txBody>
+          <a:bodyPr wrap="square">
+            <a:spAutoFit/>
+          </a:bodyPr>
+          <a:lstStyle/>
+          <a:p>
+            <a:pPr algn="l"/>
+            <a:r>
+              <a:rPr sz="1300" b="1" i="0">
+                <a:solidFill>
+                  <a:srgbClr val="FFFFFF"/>
+                </a:solidFill>
+                <a:latin typeface="Arial"/>
+              </a:rPr>
+              <a:t>→  Bearbeitung im Teilnehmer-Workbook (Arbeitsblatt mit Ausfüllfeldern)</a:t>
+            </a:r>
+          </a:p>
+        </p:txBody>
+      </p:sp>
+      <p:sp>
+        <p:nvSpPr>
+          <p:cNvPr id="11" name="Rectangle 10"/>
+          <p:cNvSpPr/>
+          <p:nvPr/>
+        </p:nvSpPr>
+        <p:spPr>
+          <a:xfrm>
+            <a:off x="0" y="6510528"/>
+            <a:ext cx="12188952" cy="347472"/>
+          </a:xfrm>
+          <a:prstGeom prst="rect">
+            <a:avLst/>
+          </a:prstGeom>
+          <a:solidFill>
+            <a:srgbClr val="0A1937"/>
+          </a:solidFill>
+          <a:ln>
+            <a:noFill/>
+          </a:ln>
+        </p:spPr>
+        <p:style>
+          <a:lnRef idx="1">
+            <a:schemeClr val="accent1"/>
+          </a:lnRef>
+          <a:fillRef idx="3">
+            <a:schemeClr val="accent1"/>
+          </a:fillRef>
+          <a:effectRef idx="2">
+            <a:schemeClr val="accent1"/>
+          </a:effectRef>
+          <a:fontRef idx="minor">
+            <a:schemeClr val="lt1"/>
+          </a:fontRef>
+        </p:style>
+        <p:txBody>
+          <a:bodyPr rtlCol="0" anchor="ctr"/>
+          <a:lstStyle/>
+          <a:p>
+            <a:pPr algn="ctr"/>
+          </a:p>
+        </p:txBody>
+      </p:sp>
+      <p:sp>
+        <p:nvSpPr>
+          <p:cNvPr id="12" name="TextBox 11"/>
+          <p:cNvSpPr txBox="1"/>
+          <p:nvPr/>
+        </p:nvSpPr>
+        <p:spPr>
+          <a:xfrm>
+            <a:off x="685800" y="6583680"/>
+            <a:ext cx="6490411" cy="256032"/>
+          </a:xfrm>
+          <a:prstGeom prst="rect">
+            <a:avLst/>
+          </a:prstGeom>
+          <a:noFill/>
+        </p:spPr>
+        <p:txBody>
+          <a:bodyPr wrap="none">
+            <a:spAutoFit/>
+          </a:bodyPr>
+          <a:lstStyle/>
+          <a:p>
+            <a:pPr algn="l"/>
+            <a:r>
+              <a:rPr sz="700">
+                <a:solidFill>
+                  <a:srgbClr val="A0B4D2"/>
+                </a:solidFill>
+                <a:latin typeface="Consolas"/>
+              </a:rPr>
+              <a:t>FKB Campus  ·  VA08</a:t>
+            </a:r>
+          </a:p>
+        </p:txBody>
+      </p:sp>
+    </p:spTree>
+  </p:cSld>
+  <p:clrMapOvr>
+    <a:masterClrMapping/>
+  </p:clrMapOvr>
+</p:sld>
+</file>
+
+<file path=ppt/slides/slide15.xml><?xml version="1.0" encoding="utf-8"?>
+<p:sld xmlns:a="http://schemas.openxmlformats.org/drawingml/2006/main" xmlns:p="http://schemas.openxmlformats.org/presentationml/2006/main" xmlns:r="http://schemas.openxmlformats.org/officeDocument/2006/relationships">
+  <p:cSld>
+    <p:spTree>
+      <p:nvGrpSpPr>
+        <p:cNvPr id="1" name=""/>
+        <p:cNvGrpSpPr/>
+        <p:nvPr/>
+      </p:nvGrpSpPr>
+      <p:grpSpPr/>
+      <p:sp>
+        <p:nvSpPr>
+          <p:cNvPr id="2" name="Rectangle 1"/>
+          <p:cNvSpPr/>
+          <p:nvPr/>
+        </p:nvSpPr>
+        <p:spPr>
+          <a:xfrm>
+            <a:off x="0" y="0"/>
+            <a:ext cx="12188952" cy="6858000"/>
+          </a:xfrm>
+          <a:prstGeom prst="rect">
+            <a:avLst/>
+          </a:prstGeom>
+          <a:solidFill>
+            <a:srgbClr val="EDEDF3"/>
+          </a:solidFill>
+          <a:ln>
+            <a:noFill/>
+          </a:ln>
+        </p:spPr>
+        <p:style>
+          <a:lnRef idx="1">
+            <a:schemeClr val="accent1"/>
+          </a:lnRef>
+          <a:fillRef idx="3">
+            <a:schemeClr val="accent1"/>
+          </a:fillRef>
+          <a:effectRef idx="2">
+            <a:schemeClr val="accent1"/>
+          </a:effectRef>
+          <a:fontRef idx="minor">
+            <a:schemeClr val="lt1"/>
+          </a:fontRef>
+        </p:style>
+        <p:txBody>
+          <a:bodyPr rtlCol="0" anchor="ctr"/>
+          <a:lstStyle/>
+          <a:p>
+            <a:pPr algn="ctr"/>
+          </a:p>
+        </p:txBody>
+      </p:sp>
+      <p:sp>
+        <p:nvSpPr>
+          <p:cNvPr id="3" name="Rectangle 2"/>
+          <p:cNvSpPr/>
+          <p:nvPr/>
+        </p:nvSpPr>
+        <p:spPr>
+          <a:xfrm>
+            <a:off x="0" y="0"/>
+            <a:ext cx="12188952" cy="50292"/>
+          </a:xfrm>
+          <a:prstGeom prst="rect">
+            <a:avLst/>
+          </a:prstGeom>
+          <a:solidFill>
+            <a:srgbClr val="1F2C56"/>
+          </a:solidFill>
+          <a:ln>
+            <a:noFill/>
+          </a:ln>
+        </p:spPr>
+        <p:style>
+          <a:lnRef idx="1">
+            <a:schemeClr val="accent1"/>
+          </a:lnRef>
+          <a:fillRef idx="3">
+            <a:schemeClr val="accent1"/>
+          </a:fillRef>
+          <a:effectRef idx="2">
+            <a:schemeClr val="accent1"/>
+          </a:effectRef>
+          <a:fontRef idx="minor">
+            <a:schemeClr val="lt1"/>
+          </a:fontRef>
+        </p:style>
+        <p:txBody>
+          <a:bodyPr rtlCol="0" anchor="ctr"/>
+          <a:lstStyle/>
+          <a:p>
+            <a:pPr algn="ctr"/>
+          </a:p>
+        </p:txBody>
+      </p:sp>
+      <p:sp>
+        <p:nvSpPr>
+          <p:cNvPr id="4" name="TextBox 3"/>
+          <p:cNvSpPr txBox="1"/>
+          <p:nvPr/>
+        </p:nvSpPr>
+        <p:spPr>
+          <a:xfrm>
+            <a:off x="685800" y="109728"/>
+            <a:ext cx="10817352" cy="228600"/>
+          </a:xfrm>
+          <a:prstGeom prst="rect">
+            <a:avLst/>
+          </a:prstGeom>
+          <a:noFill/>
+        </p:spPr>
+        <p:txBody>
+          <a:bodyPr wrap="none">
+            <a:spAutoFit/>
+          </a:bodyPr>
+          <a:lstStyle/>
+          <a:p>
+            <a:pPr algn="l"/>
+            <a:r>
+              <a:rPr sz="750">
+                <a:solidFill>
+                  <a:srgbClr val="78808C"/>
+                </a:solidFill>
+                <a:latin typeface="Consolas"/>
+              </a:rPr>
+              <a:t>VA08  ·  INHALT</a:t>
+            </a:r>
+          </a:p>
+        </p:txBody>
+      </p:sp>
+      <p:sp>
+        <p:nvSpPr>
+          <p:cNvPr id="5" name="Rectangle 4"/>
+          <p:cNvSpPr/>
+          <p:nvPr/>
+        </p:nvSpPr>
+        <p:spPr>
+          <a:xfrm>
+            <a:off x="0" y="1234440"/>
+            <a:ext cx="12188952" cy="12700"/>
+          </a:xfrm>
+          <a:prstGeom prst="rect">
+            <a:avLst/>
+          </a:prstGeom>
+          <a:solidFill>
+            <a:srgbClr val="D8DFE4"/>
+          </a:solidFill>
+          <a:ln>
+            <a:noFill/>
+          </a:ln>
+        </p:spPr>
+        <p:style>
+          <a:lnRef idx="1">
+            <a:schemeClr val="accent1"/>
+          </a:lnRef>
+          <a:fillRef idx="3">
+            <a:schemeClr val="accent1"/>
+          </a:fillRef>
+          <a:effectRef idx="2">
+            <a:schemeClr val="accent1"/>
+          </a:effectRef>
+          <a:fontRef idx="minor">
+            <a:schemeClr val="lt1"/>
+          </a:fontRef>
+        </p:style>
+        <p:txBody>
+          <a:bodyPr rtlCol="0" anchor="ctr"/>
+          <a:lstStyle/>
+          <a:p>
+            <a:pPr algn="ctr"/>
+          </a:p>
+        </p:txBody>
+      </p:sp>
+      <p:sp>
+        <p:nvSpPr>
+          <p:cNvPr id="6" name="Rectangle 5"/>
+          <p:cNvSpPr/>
+          <p:nvPr/>
+        </p:nvSpPr>
+        <p:spPr>
+          <a:xfrm>
+            <a:off x="685800" y="502920"/>
+            <a:ext cx="36576" cy="658368"/>
+          </a:xfrm>
+          <a:prstGeom prst="rect">
+            <a:avLst/>
+          </a:prstGeom>
+          <a:solidFill>
+            <a:srgbClr val="D9C089"/>
+          </a:solidFill>
+          <a:ln>
+            <a:noFill/>
+          </a:ln>
+        </p:spPr>
+        <p:style>
+          <a:lnRef idx="1">
+            <a:schemeClr val="accent1"/>
+          </a:lnRef>
+          <a:fillRef idx="3">
+            <a:schemeClr val="accent1"/>
+          </a:fillRef>
+          <a:effectRef idx="2">
+            <a:schemeClr val="accent1"/>
+          </a:effectRef>
+          <a:fontRef idx="minor">
+            <a:schemeClr val="lt1"/>
+          </a:fontRef>
+        </p:style>
+        <p:txBody>
+          <a:bodyPr rtlCol="0" anchor="ctr"/>
+          <a:lstStyle/>
+          <a:p>
+            <a:pPr algn="ctr"/>
+          </a:p>
+        </p:txBody>
+      </p:sp>
+      <p:sp>
+        <p:nvSpPr>
+          <p:cNvPr id="7" name="TextBox 6"/>
+          <p:cNvSpPr txBox="1"/>
+          <p:nvPr/>
+        </p:nvSpPr>
+        <p:spPr>
+          <a:xfrm>
+            <a:off x="813816" y="502920"/>
+            <a:ext cx="10634472" cy="685800"/>
+          </a:xfrm>
+          <a:prstGeom prst="rect">
+            <a:avLst/>
+          </a:prstGeom>
+          <a:noFill/>
+        </p:spPr>
+        <p:txBody>
+          <a:bodyPr wrap="square">
+            <a:spAutoFit/>
+          </a:bodyPr>
+          <a:lstStyle/>
+          <a:p>
+            <a:pPr algn="l"/>
+            <a:r>
+              <a:rPr sz="2400" b="1" i="0">
+                <a:solidFill>
+                  <a:srgbClr val="1F2C56"/>
+                </a:solidFill>
+                <a:latin typeface="Arial"/>
+              </a:rPr>
+              <a:t>Prinzip dieses Moduls</a:t>
+            </a:r>
+          </a:p>
+        </p:txBody>
+      </p:sp>
+      <p:sp>
+        <p:nvSpPr>
+          <p:cNvPr id="8" name="TextBox 7"/>
+          <p:cNvSpPr txBox="1"/>
+          <p:nvPr/>
+        </p:nvSpPr>
+        <p:spPr>
+          <a:xfrm>
+            <a:off x="685800" y="1417320"/>
+            <a:ext cx="10817352" cy="4892040"/>
+          </a:xfrm>
+          <a:prstGeom prst="rect">
+            <a:avLst/>
+          </a:prstGeom>
+          <a:noFill/>
+        </p:spPr>
+        <p:txBody>
+          <a:bodyPr wrap="square" anchor="ctr">
+            <a:spAutoFit/>
+          </a:bodyPr>
+          <a:lstStyle/>
+          <a:p>
+            <a:pPr marL="177800" indent="-177800">
+              <a:spcBef>
+                <a:spcPts val="600"/>
+              </a:spcBef>
+              <a:spcAft>
+                <a:spcPts val="200"/>
+              </a:spcAft>
+            </a:pPr>
+            <a:r>
+              <a:rPr sz="1200" i="1">
+                <a:solidFill>
+                  <a:srgbClr val="3D5466"/>
+                </a:solidFill>
+                <a:latin typeface="Arial"/>
+              </a:rPr>
+              <a:t>→  Wichtig geht vor dringend.</a:t>
+            </a:r>
+          </a:p>
+          <a:p>
+            <a:pPr marL="190500" indent="-190500">
+              <a:spcBef>
+                <a:spcPts val="400"/>
+              </a:spcBef>
+              <a:spcAft>
+                <a:spcPts val="200"/>
+              </a:spcAft>
+            </a:pPr>
+            <a:r>
+              <a:rPr sz="1300">
+                <a:solidFill>
+                  <a:srgbClr val="3D5466"/>
+                </a:solidFill>
+                <a:latin typeface="Arial"/>
+              </a:rPr>
+              <a:t>▸  Wer nach Wichtigkeit statt nur nach Lautstärke priorisiert, gewinnt Kontrolle statt Getriebensein.</a:t>
+            </a:r>
+          </a:p>
+        </p:txBody>
+      </p:sp>
+      <p:sp>
+        <p:nvSpPr>
+          <p:cNvPr id="9" name="Rectangle 8"/>
+          <p:cNvSpPr/>
+          <p:nvPr/>
+        </p:nvSpPr>
+        <p:spPr>
+          <a:xfrm>
+            <a:off x="0" y="6510528"/>
+            <a:ext cx="12188952" cy="347472"/>
+          </a:xfrm>
+          <a:prstGeom prst="rect">
+            <a:avLst/>
+          </a:prstGeom>
+          <a:solidFill>
+            <a:srgbClr val="0A1937"/>
+          </a:solidFill>
+          <a:ln>
+            <a:noFill/>
+          </a:ln>
+        </p:spPr>
+        <p:style>
+          <a:lnRef idx="1">
+            <a:schemeClr val="accent1"/>
+          </a:lnRef>
+          <a:fillRef idx="3">
+            <a:schemeClr val="accent1"/>
+          </a:fillRef>
+          <a:effectRef idx="2">
+            <a:schemeClr val="accent1"/>
+          </a:effectRef>
+          <a:fontRef idx="minor">
+            <a:schemeClr val="lt1"/>
+          </a:fontRef>
+        </p:style>
+        <p:txBody>
+          <a:bodyPr rtlCol="0" anchor="ctr"/>
+          <a:lstStyle/>
+          <a:p>
+            <a:pPr algn="ctr"/>
+          </a:p>
+        </p:txBody>
+      </p:sp>
+      <p:sp>
+        <p:nvSpPr>
+          <p:cNvPr id="10" name="TextBox 9"/>
+          <p:cNvSpPr txBox="1"/>
+          <p:nvPr/>
+        </p:nvSpPr>
+        <p:spPr>
+          <a:xfrm>
+            <a:off x="685800" y="6583680"/>
+            <a:ext cx="6490411" cy="256032"/>
+          </a:xfrm>
+          <a:prstGeom prst="rect">
+            <a:avLst/>
+          </a:prstGeom>
+          <a:noFill/>
+        </p:spPr>
+        <p:txBody>
+          <a:bodyPr wrap="none">
+            <a:spAutoFit/>
+          </a:bodyPr>
+          <a:lstStyle/>
+          <a:p>
+            <a:pPr algn="l"/>
+            <a:r>
+              <a:rPr sz="700">
+                <a:solidFill>
+                  <a:srgbClr val="A0B4D2"/>
+                </a:solidFill>
+                <a:latin typeface="Consolas"/>
+              </a:rPr>
+              <a:t>FKB Campus  ·  VA08</a:t>
+            </a:r>
+          </a:p>
+        </p:txBody>
+      </p:sp>
+    </p:spTree>
+  </p:cSld>
+  <p:clrMapOvr>
+    <a:masterClrMapping/>
+  </p:clrMapOvr>
+</p:sld>
+</file>
+
+<file path=ppt/slides/slide16.xml><?xml version="1.0" encoding="utf-8"?>
+<p:sld xmlns:a="http://schemas.openxmlformats.org/drawingml/2006/main" xmlns:p="http://schemas.openxmlformats.org/presentationml/2006/main" xmlns:r="http://schemas.openxmlformats.org/officeDocument/2006/relationships">
+  <p:cSld>
+    <p:spTree>
+      <p:nvGrpSpPr>
+        <p:cNvPr id="1" name=""/>
+        <p:cNvGrpSpPr/>
+        <p:nvPr/>
+      </p:nvGrpSpPr>
+      <p:grpSpPr/>
+      <p:sp>
+        <p:nvSpPr>
+          <p:cNvPr id="2" name="Rectangle 1"/>
+          <p:cNvSpPr/>
+          <p:nvPr/>
+        </p:nvSpPr>
+        <p:spPr>
+          <a:xfrm>
+            <a:off x="0" y="0"/>
+            <a:ext cx="12188952" cy="6858000"/>
+          </a:xfrm>
+          <a:prstGeom prst="rect">
+            <a:avLst/>
+          </a:prstGeom>
+          <a:solidFill>
+            <a:srgbClr val="EDEDF3"/>
+          </a:solidFill>
+          <a:ln>
+            <a:noFill/>
+          </a:ln>
+        </p:spPr>
+        <p:style>
+          <a:lnRef idx="1">
+            <a:schemeClr val="accent1"/>
+          </a:lnRef>
+          <a:fillRef idx="3">
+            <a:schemeClr val="accent1"/>
+          </a:fillRef>
+          <a:effectRef idx="2">
+            <a:schemeClr val="accent1"/>
+          </a:effectRef>
+          <a:fontRef idx="minor">
+            <a:schemeClr val="lt1"/>
+          </a:fontRef>
+        </p:style>
+        <p:txBody>
+          <a:bodyPr rtlCol="0" anchor="ctr"/>
+          <a:lstStyle/>
+          <a:p>
+            <a:pPr algn="ctr"/>
+          </a:p>
+        </p:txBody>
+      </p:sp>
+      <p:sp>
+        <p:nvSpPr>
+          <p:cNvPr id="3" name="Rectangle 2"/>
+          <p:cNvSpPr/>
+          <p:nvPr/>
+        </p:nvSpPr>
+        <p:spPr>
+          <a:xfrm>
+            <a:off x="0" y="0"/>
+            <a:ext cx="12188952" cy="50292"/>
+          </a:xfrm>
+          <a:prstGeom prst="rect">
+            <a:avLst/>
+          </a:prstGeom>
+          <a:solidFill>
+            <a:srgbClr val="1F2C56"/>
+          </a:solidFill>
+          <a:ln>
+            <a:noFill/>
+          </a:ln>
+        </p:spPr>
+        <p:style>
+          <a:lnRef idx="1">
+            <a:schemeClr val="accent1"/>
+          </a:lnRef>
+          <a:fillRef idx="3">
+            <a:schemeClr val="accent1"/>
+          </a:fillRef>
+          <a:effectRef idx="2">
+            <a:schemeClr val="accent1"/>
+          </a:effectRef>
+          <a:fontRef idx="minor">
+            <a:schemeClr val="lt1"/>
+          </a:fontRef>
+        </p:style>
+        <p:txBody>
+          <a:bodyPr rtlCol="0" anchor="ctr"/>
+          <a:lstStyle/>
+          <a:p>
+            <a:pPr algn="ctr"/>
+          </a:p>
+        </p:txBody>
+      </p:sp>
+      <p:sp>
+        <p:nvSpPr>
+          <p:cNvPr id="4" name="TextBox 3"/>
+          <p:cNvSpPr txBox="1"/>
+          <p:nvPr/>
+        </p:nvSpPr>
+        <p:spPr>
+          <a:xfrm>
+            <a:off x="685800" y="109728"/>
+            <a:ext cx="10817352" cy="228600"/>
+          </a:xfrm>
+          <a:prstGeom prst="rect">
+            <a:avLst/>
+          </a:prstGeom>
+          <a:noFill/>
+        </p:spPr>
+        <p:txBody>
+          <a:bodyPr wrap="none">
+            <a:spAutoFit/>
+          </a:bodyPr>
+          <a:lstStyle/>
+          <a:p>
+            <a:pPr algn="l"/>
+            <a:r>
+              <a:rPr sz="750">
+                <a:solidFill>
+                  <a:srgbClr val="78808C"/>
+                </a:solidFill>
+                <a:latin typeface="Consolas"/>
+              </a:rPr>
+              <a:t>VA08  ·  INHALT</a:t>
+            </a:r>
+          </a:p>
+        </p:txBody>
+      </p:sp>
+      <p:sp>
+        <p:nvSpPr>
+          <p:cNvPr id="5" name="Rectangle 4"/>
+          <p:cNvSpPr/>
+          <p:nvPr/>
+        </p:nvSpPr>
+        <p:spPr>
+          <a:xfrm>
+            <a:off x="0" y="1234440"/>
+            <a:ext cx="12188952" cy="12700"/>
+          </a:xfrm>
+          <a:prstGeom prst="rect">
+            <a:avLst/>
+          </a:prstGeom>
+          <a:solidFill>
+            <a:srgbClr val="D8DFE4"/>
+          </a:solidFill>
+          <a:ln>
+            <a:noFill/>
+          </a:ln>
+        </p:spPr>
+        <p:style>
+          <a:lnRef idx="1">
+            <a:schemeClr val="accent1"/>
+          </a:lnRef>
+          <a:fillRef idx="3">
+            <a:schemeClr val="accent1"/>
+          </a:fillRef>
+          <a:effectRef idx="2">
+            <a:schemeClr val="accent1"/>
+          </a:effectRef>
+          <a:fontRef idx="minor">
+            <a:schemeClr val="lt1"/>
+          </a:fontRef>
+        </p:style>
+        <p:txBody>
+          <a:bodyPr rtlCol="0" anchor="ctr"/>
+          <a:lstStyle/>
+          <a:p>
+            <a:pPr algn="ctr"/>
+          </a:p>
+        </p:txBody>
+      </p:sp>
+      <p:sp>
+        <p:nvSpPr>
+          <p:cNvPr id="6" name="Rectangle 5"/>
+          <p:cNvSpPr/>
+          <p:nvPr/>
+        </p:nvSpPr>
+        <p:spPr>
+          <a:xfrm>
+            <a:off x="685800" y="502920"/>
+            <a:ext cx="36576" cy="658368"/>
+          </a:xfrm>
+          <a:prstGeom prst="rect">
+            <a:avLst/>
+          </a:prstGeom>
+          <a:solidFill>
+            <a:srgbClr val="D9C089"/>
+          </a:solidFill>
+          <a:ln>
+            <a:noFill/>
+          </a:ln>
+        </p:spPr>
+        <p:style>
+          <a:lnRef idx="1">
+            <a:schemeClr val="accent1"/>
+          </a:lnRef>
+          <a:fillRef idx="3">
+            <a:schemeClr val="accent1"/>
+          </a:fillRef>
+          <a:effectRef idx="2">
+            <a:schemeClr val="accent1"/>
+          </a:effectRef>
+          <a:fontRef idx="minor">
+            <a:schemeClr val="lt1"/>
+          </a:fontRef>
+        </p:style>
+        <p:txBody>
+          <a:bodyPr rtlCol="0" anchor="ctr"/>
+          <a:lstStyle/>
+          <a:p>
+            <a:pPr algn="ctr"/>
+          </a:p>
+        </p:txBody>
+      </p:sp>
+      <p:sp>
+        <p:nvSpPr>
+          <p:cNvPr id="7" name="TextBox 6"/>
+          <p:cNvSpPr txBox="1"/>
+          <p:nvPr/>
+        </p:nvSpPr>
+        <p:spPr>
+          <a:xfrm>
+            <a:off x="813816" y="502920"/>
+            <a:ext cx="10634472" cy="685800"/>
+          </a:xfrm>
+          <a:prstGeom prst="rect">
+            <a:avLst/>
+          </a:prstGeom>
+          <a:noFill/>
+        </p:spPr>
+        <p:txBody>
+          <a:bodyPr wrap="square">
+            <a:spAutoFit/>
+          </a:bodyPr>
+          <a:lstStyle/>
+          <a:p>
+            <a:pPr algn="l"/>
+            <a:r>
+              <a:rPr sz="2400" b="1" i="0">
+                <a:solidFill>
+                  <a:srgbClr val="1F2C56"/>
+                </a:solidFill>
+                <a:latin typeface="Arial"/>
+              </a:rPr>
+              <a:t>Reflexionsfragen</a:t>
+            </a:r>
+          </a:p>
+        </p:txBody>
+      </p:sp>
+      <p:sp>
+        <p:nvSpPr>
+          <p:cNvPr id="8" name="TextBox 7"/>
+          <p:cNvSpPr txBox="1"/>
+          <p:nvPr/>
+        </p:nvSpPr>
+        <p:spPr>
+          <a:xfrm>
+            <a:off x="685800" y="1417320"/>
+            <a:ext cx="10817352" cy="4892040"/>
+          </a:xfrm>
+          <a:prstGeom prst="rect">
+            <a:avLst/>
+          </a:prstGeom>
+          <a:noFill/>
+        </p:spPr>
+        <p:txBody>
+          <a:bodyPr wrap="square" anchor="ctr">
+            <a:spAutoFit/>
+          </a:bodyPr>
+          <a:lstStyle/>
+          <a:p>
+            <a:pPr marL="190500" indent="-190500">
+              <a:spcBef>
+                <a:spcPts val="400"/>
+              </a:spcBef>
+              <a:spcAft>
+                <a:spcPts val="200"/>
+              </a:spcAft>
+            </a:pPr>
+            <a:r>
+              <a:rPr sz="1300">
+                <a:solidFill>
+                  <a:srgbClr val="3D5466"/>
+                </a:solidFill>
+                <a:latin typeface="Arial"/>
+              </a:rPr>
+              <a:t>▸  Welche wichtige, aber nicht dringende Aufgabe schieben Sie regelmäßig auf – und was kostet das?</a:t>
+            </a:r>
+          </a:p>
+          <a:p>
+            <a:pPr marL="190500" indent="-190500">
+              <a:spcBef>
+                <a:spcPts val="400"/>
+              </a:spcBef>
+              <a:spcAft>
+                <a:spcPts val="200"/>
+              </a:spcAft>
+            </a:pPr>
+            <a:r>
+              <a:rPr sz="1300">
+                <a:solidFill>
+                  <a:srgbClr val="3D5466"/>
+                </a:solidFill>
+                <a:latin typeface="Arial"/>
+              </a:rPr>
+              <a:t>▸  Welcher Zeitfresser frisst bei Ihnen am meisten Zeit, und welches der drei Gegenmittel passt?</a:t>
+            </a:r>
+          </a:p>
+          <a:p>
+            <a:pPr marL="190500" indent="-190500">
+              <a:spcBef>
+                <a:spcPts val="400"/>
+              </a:spcBef>
+              <a:spcAft>
+                <a:spcPts val="200"/>
+              </a:spcAft>
+            </a:pPr>
+            <a:r>
+              <a:rPr sz="1300">
+                <a:solidFill>
+                  <a:srgbClr val="3D5466"/>
+                </a:solidFill>
+                <a:latin typeface="Arial"/>
+              </a:rPr>
+              <a:t>▸  Wann in Ihrer Woche wäre Platz für einen geschützten Bearbeitungsblock?</a:t>
+            </a:r>
+          </a:p>
+        </p:txBody>
+      </p:sp>
+      <p:sp>
+        <p:nvSpPr>
+          <p:cNvPr id="9" name="Rectangle 8"/>
+          <p:cNvSpPr/>
+          <p:nvPr/>
+        </p:nvSpPr>
+        <p:spPr>
+          <a:xfrm>
+            <a:off x="0" y="6510528"/>
+            <a:ext cx="12188952" cy="347472"/>
+          </a:xfrm>
+          <a:prstGeom prst="rect">
+            <a:avLst/>
+          </a:prstGeom>
+          <a:solidFill>
+            <a:srgbClr val="0A1937"/>
+          </a:solidFill>
+          <a:ln>
+            <a:noFill/>
+          </a:ln>
+        </p:spPr>
+        <p:style>
+          <a:lnRef idx="1">
+            <a:schemeClr val="accent1"/>
+          </a:lnRef>
+          <a:fillRef idx="3">
+            <a:schemeClr val="accent1"/>
+          </a:fillRef>
+          <a:effectRef idx="2">
+            <a:schemeClr val="accent1"/>
+          </a:effectRef>
+          <a:fontRef idx="minor">
+            <a:schemeClr val="lt1"/>
+          </a:fontRef>
+        </p:style>
+        <p:txBody>
+          <a:bodyPr rtlCol="0" anchor="ctr"/>
+          <a:lstStyle/>
+          <a:p>
+            <a:pPr algn="ctr"/>
+          </a:p>
+        </p:txBody>
+      </p:sp>
+      <p:sp>
+        <p:nvSpPr>
+          <p:cNvPr id="10" name="TextBox 9"/>
+          <p:cNvSpPr txBox="1"/>
+          <p:nvPr/>
+        </p:nvSpPr>
+        <p:spPr>
+          <a:xfrm>
+            <a:off x="685800" y="6583680"/>
+            <a:ext cx="6490411" cy="256032"/>
+          </a:xfrm>
+          <a:prstGeom prst="rect">
+            <a:avLst/>
+          </a:prstGeom>
+          <a:noFill/>
+        </p:spPr>
+        <p:txBody>
+          <a:bodyPr wrap="none">
+            <a:spAutoFit/>
+          </a:bodyPr>
+          <a:lstStyle/>
+          <a:p>
+            <a:pPr algn="l"/>
+            <a:r>
+              <a:rPr sz="700">
+                <a:solidFill>
+                  <a:srgbClr val="A0B4D2"/>
+                </a:solidFill>
+                <a:latin typeface="Consolas"/>
+              </a:rPr>
+              <a:t>FKB Campus  ·  VA08</a:t>
+            </a:r>
+          </a:p>
+        </p:txBody>
+      </p:sp>
+    </p:spTree>
+  </p:cSld>
+  <p:clrMapOvr>
+    <a:masterClrMapping/>
+  </p:clrMapOvr>
+</p:sld>
+</file>
+
 <file path=ppt/slides/slide2.xml><?xml version="1.0" encoding="utf-8"?>
 <p:sld xmlns:a="http://schemas.openxmlformats.org/drawingml/2006/main" xmlns:p="http://schemas.openxmlformats.org/presentationml/2006/main" xmlns:r="http://schemas.openxmlformats.org/officeDocument/2006/relationships">
   <p:cSld>
@@ -5813,7 +8989,7 @@
             <a:avLst/>
           </a:prstGeom>
           <a:solidFill>
-            <a:srgbClr val="FFFFFF"/>
+            <a:srgbClr val="1F2C56"/>
           </a:solidFill>
           <a:ln>
             <a:noFill/>
@@ -5843,57 +9019,14 @@
       </p:sp>
       <p:sp>
         <p:nvSpPr>
-          <p:cNvPr id="3" name="Rectangle 2"/>
-          <p:cNvSpPr/>
-          <p:nvPr/>
-        </p:nvSpPr>
-        <p:spPr>
-          <a:xfrm>
-            <a:off x="0" y="0"/>
-            <a:ext cx="12188952" cy="50292"/>
-          </a:xfrm>
-          <a:prstGeom prst="rect">
-            <a:avLst/>
-          </a:prstGeom>
-          <a:solidFill>
-            <a:srgbClr val="1F2C56"/>
-          </a:solidFill>
-          <a:ln>
-            <a:noFill/>
-          </a:ln>
-        </p:spPr>
-        <p:style>
-          <a:lnRef idx="1">
-            <a:schemeClr val="accent1"/>
-          </a:lnRef>
-          <a:fillRef idx="3">
-            <a:schemeClr val="accent1"/>
-          </a:fillRef>
-          <a:effectRef idx="2">
-            <a:schemeClr val="accent1"/>
-          </a:effectRef>
-          <a:fontRef idx="minor">
-            <a:schemeClr val="lt1"/>
-          </a:fontRef>
-        </p:style>
-        <p:txBody>
-          <a:bodyPr rtlCol="0" anchor="ctr"/>
-          <a:lstStyle/>
-          <a:p>
-            <a:pPr algn="ctr"/>
-          </a:p>
-        </p:txBody>
-      </p:sp>
-      <p:sp>
-        <p:nvSpPr>
-          <p:cNvPr id="4" name="TextBox 3"/>
+          <p:cNvPr id="3" name="TextBox 2"/>
           <p:cNvSpPr txBox="1"/>
           <p:nvPr/>
         </p:nvSpPr>
         <p:spPr>
           <a:xfrm>
-            <a:off x="685800" y="109728"/>
-            <a:ext cx="10817352" cy="228600"/>
+            <a:off x="685800" y="2377440"/>
+            <a:ext cx="10817352" cy="365760"/>
           </a:xfrm>
           <a:prstGeom prst="rect">
             <a:avLst/>
@@ -5908,62 +9041,27 @@
           <a:p>
             <a:pPr algn="l"/>
             <a:r>
-              <a:rPr sz="750">
-                <a:solidFill>
-                  <a:srgbClr val="78808C"/>
+              <a:rPr sz="1200">
+                <a:solidFill>
+                  <a:srgbClr val="D9C089"/>
                 </a:solidFill>
                 <a:latin typeface="Consolas"/>
               </a:rPr>
-              <a:t>VA08  ·  ÜBERSICHT</a:t>
-            </a:r>
-          </a:p>
-        </p:txBody>
-      </p:sp>
-      <p:sp>
-        <p:nvSpPr>
-          <p:cNvPr id="5" name="TextBox 4"/>
-          <p:cNvSpPr txBox="1"/>
-          <p:nvPr/>
-        </p:nvSpPr>
-        <p:spPr>
-          <a:xfrm>
-            <a:off x="685800" y="502920"/>
-            <a:ext cx="10817352" cy="594360"/>
-          </a:xfrm>
-          <a:prstGeom prst="rect">
-            <a:avLst/>
-          </a:prstGeom>
-          <a:noFill/>
-        </p:spPr>
-        <p:txBody>
-          <a:bodyPr wrap="square">
-            <a:spAutoFit/>
-          </a:bodyPr>
-          <a:lstStyle/>
-          <a:p>
-            <a:pPr algn="l"/>
-            <a:r>
-              <a:rPr sz="2000" b="1" i="0">
-                <a:solidFill>
-                  <a:srgbClr val="1F2C56"/>
-                </a:solidFill>
-                <a:latin typeface="Arial"/>
-              </a:rPr>
-              <a:t>Theorie-Input: Wichtig ist nicht gleich dringend</a:t>
-            </a:r>
-          </a:p>
-        </p:txBody>
-      </p:sp>
-      <p:sp>
-        <p:nvSpPr>
-          <p:cNvPr id="6" name="Rectangle 5"/>
+              <a:t>00:05–00:20</a:t>
+            </a:r>
+          </a:p>
+        </p:txBody>
+      </p:sp>
+      <p:sp>
+        <p:nvSpPr>
+          <p:cNvPr id="4" name="Rectangle 3"/>
           <p:cNvSpPr/>
           <p:nvPr/>
         </p:nvSpPr>
         <p:spPr>
           <a:xfrm>
-            <a:off x="685800" y="1143000"/>
-            <a:ext cx="10817352" cy="25400"/>
+            <a:off x="685800" y="2788920"/>
+            <a:ext cx="548640" cy="38100"/>
           </a:xfrm>
           <a:prstGeom prst="rect">
             <a:avLst/>
@@ -5997,256 +9095,86 @@
           </a:p>
         </p:txBody>
       </p:sp>
-      <p:graphicFrame>
-        <p:nvGraphicFramePr>
-          <p:cNvPr id="7" name="Table 6"/>
-          <p:cNvGraphicFramePr>
-            <a:graphicFrameLocks noGrp="1"/>
-          </p:cNvGraphicFramePr>
-          <p:nvPr/>
-        </p:nvGraphicFramePr>
-        <p:xfrm>
-          <a:off x="685800" y="1417320"/>
-          <a:ext cx="10817352" cy="1152144"/>
-        </p:xfrm>
-        <a:graphic>
-          <a:graphicData uri="http://schemas.openxmlformats.org/drawingml/2006/table">
-            <a:tbl>
-              <a:tblPr firstRow="1" bandRow="1">
-                <a:tableStyleId>{5C22544A-7EE6-4342-B048-85BDC9FD1C3A}</a:tableStyleId>
-              </a:tblPr>
-              <a:tblGrid>
-                <a:gridCol w="3605784"/>
-                <a:gridCol w="3605784"/>
-                <a:gridCol w="3605784"/>
-              </a:tblGrid>
-              <a:tr h="384048">
-                <a:tc>
-                  <a:txBody>
-                    <a:bodyPr/>
-                    <a:lstStyle/>
-                    <a:p/>
-                  </a:txBody>
-                  <a:tcPr>
-                    <a:solidFill>
-                      <a:srgbClr val="1F2C56"/>
-                    </a:solidFill>
-                  </a:tcPr>
-                </a:tc>
-                <a:tc>
-                  <a:txBody>
-                    <a:bodyPr/>
-                    <a:lstStyle/>
-                    <a:p>
-                      <a:r>
-                        <a:rPr sz="1100" b="1">
-                          <a:solidFill>
-                            <a:srgbClr val="FFFFFF"/>
-                          </a:solidFill>
-                          <a:latin typeface="Arial"/>
-                        </a:rPr>
-                        <a:t>dringend</a:t>
-                      </a:r>
-                    </a:p>
-                  </a:txBody>
-                  <a:tcPr>
-                    <a:solidFill>
-                      <a:srgbClr val="1F2C56"/>
-                    </a:solidFill>
-                  </a:tcPr>
-                </a:tc>
-                <a:tc>
-                  <a:txBody>
-                    <a:bodyPr/>
-                    <a:lstStyle/>
-                    <a:p>
-                      <a:r>
-                        <a:rPr sz="1100" b="1">
-                          <a:solidFill>
-                            <a:srgbClr val="FFFFFF"/>
-                          </a:solidFill>
-                          <a:latin typeface="Arial"/>
-                        </a:rPr>
-                        <a:t>nicht dringend</a:t>
-                      </a:r>
-                    </a:p>
-                  </a:txBody>
-                  <a:tcPr>
-                    <a:solidFill>
-                      <a:srgbClr val="1F2C56"/>
-                    </a:solidFill>
-                  </a:tcPr>
-                </a:tc>
-              </a:tr>
-              <a:tr h="384048">
-                <a:tc>
-                  <a:txBody>
-                    <a:bodyPr/>
-                    <a:lstStyle/>
-                    <a:p>
-                      <a:r>
-                        <a:rPr sz="1050">
-                          <a:solidFill>
-                            <a:srgbClr val="3D5466"/>
-                          </a:solidFill>
-                          <a:latin typeface="Arial"/>
-                        </a:rPr>
-                        <a:t>wichtig</a:t>
-                      </a:r>
-                    </a:p>
-                  </a:txBody>
-                  <a:tcPr/>
-                </a:tc>
-                <a:tc>
-                  <a:txBody>
-                    <a:bodyPr/>
-                    <a:lstStyle/>
-                    <a:p>
-                      <a:r>
-                        <a:rPr sz="1050">
-                          <a:solidFill>
-                            <a:srgbClr val="3D5466"/>
-                          </a:solidFill>
-                          <a:latin typeface="Arial"/>
-                        </a:rPr>
-                        <a:t>sofort selbst erledigen</a:t>
-                      </a:r>
-                    </a:p>
-                  </a:txBody>
-                  <a:tcPr/>
-                </a:tc>
-                <a:tc>
-                  <a:txBody>
-                    <a:bodyPr/>
-                    <a:lstStyle/>
-                    <a:p>
-                      <a:r>
-                        <a:rPr sz="1050">
-                          <a:solidFill>
-                            <a:srgbClr val="3D5466"/>
-                          </a:solidFill>
-                          <a:latin typeface="Arial"/>
-                        </a:rPr>
-                        <a:t>terminieren / einplanen</a:t>
-                      </a:r>
-                    </a:p>
-                  </a:txBody>
-                  <a:tcPr/>
-                </a:tc>
-              </a:tr>
-              <a:tr h="384048">
-                <a:tc>
-                  <a:txBody>
-                    <a:bodyPr/>
-                    <a:lstStyle/>
-                    <a:p>
-                      <a:r>
-                        <a:rPr sz="1050">
-                          <a:solidFill>
-                            <a:srgbClr val="3D5466"/>
-                          </a:solidFill>
-                          <a:latin typeface="Arial"/>
-                        </a:rPr>
-                        <a:t>nicht wichtig</a:t>
-                      </a:r>
-                    </a:p>
-                  </a:txBody>
-                  <a:tcPr/>
-                </a:tc>
-                <a:tc>
-                  <a:txBody>
-                    <a:bodyPr/>
-                    <a:lstStyle/>
-                    <a:p>
-                      <a:r>
-                        <a:rPr sz="1050">
-                          <a:solidFill>
-                            <a:srgbClr val="3D5466"/>
-                          </a:solidFill>
-                          <a:latin typeface="Arial"/>
-                        </a:rPr>
-                        <a:t>delegieren / schnell abarbeiten</a:t>
-                      </a:r>
-                    </a:p>
-                  </a:txBody>
-                  <a:tcPr/>
-                </a:tc>
-                <a:tc>
-                  <a:txBody>
-                    <a:bodyPr/>
-                    <a:lstStyle/>
-                    <a:p>
-                      <a:r>
-                        <a:rPr sz="1050">
-                          <a:solidFill>
-                            <a:srgbClr val="3D5466"/>
-                          </a:solidFill>
-                          <a:latin typeface="Arial"/>
-                        </a:rPr>
-                        <a:t>weglassen / sammeln</a:t>
-                      </a:r>
-                    </a:p>
-                  </a:txBody>
-                  <a:tcPr/>
-                </a:tc>
-              </a:tr>
-            </a:tbl>
-          </a:graphicData>
-        </a:graphic>
-      </p:graphicFrame>
-      <p:sp>
-        <p:nvSpPr>
-          <p:cNvPr id="8" name="Rectangle 7"/>
-          <p:cNvSpPr/>
-          <p:nvPr/>
-        </p:nvSpPr>
-        <p:spPr>
-          <a:xfrm>
-            <a:off x="0" y="6510528"/>
-            <a:ext cx="12188952" cy="347472"/>
-          </a:xfrm>
-          <a:prstGeom prst="rect">
-            <a:avLst/>
-          </a:prstGeom>
-          <a:solidFill>
-            <a:srgbClr val="0A1937"/>
-          </a:solidFill>
-          <a:ln>
-            <a:noFill/>
-          </a:ln>
-        </p:spPr>
-        <p:style>
-          <a:lnRef idx="1">
-            <a:schemeClr val="accent1"/>
-          </a:lnRef>
-          <a:fillRef idx="3">
-            <a:schemeClr val="accent1"/>
-          </a:fillRef>
-          <a:effectRef idx="2">
-            <a:schemeClr val="accent1"/>
-          </a:effectRef>
-          <a:fontRef idx="minor">
-            <a:schemeClr val="lt1"/>
-          </a:fontRef>
-        </p:style>
-        <p:txBody>
-          <a:bodyPr rtlCol="0" anchor="ctr"/>
-          <a:lstStyle/>
-          <a:p>
-            <a:pPr algn="ctr"/>
-          </a:p>
-        </p:txBody>
-      </p:sp>
-      <p:sp>
-        <p:nvSpPr>
-          <p:cNvPr id="9" name="TextBox 8"/>
+      <p:sp>
+        <p:nvSpPr>
+          <p:cNvPr id="5" name="TextBox 4"/>
           <p:cNvSpPr txBox="1"/>
           <p:nvPr/>
         </p:nvSpPr>
         <p:spPr>
           <a:xfrm>
-            <a:off x="685800" y="6583680"/>
-            <a:ext cx="6490411" cy="256032"/>
+            <a:off x="685800" y="3017520"/>
+            <a:ext cx="10817352" cy="1463040"/>
+          </a:xfrm>
+          <a:prstGeom prst="rect">
+            <a:avLst/>
+          </a:prstGeom>
+          <a:noFill/>
+        </p:spPr>
+        <p:txBody>
+          <a:bodyPr wrap="square">
+            <a:spAutoFit/>
+          </a:bodyPr>
+          <a:lstStyle/>
+          <a:p>
+            <a:pPr algn="l"/>
+            <a:r>
+              <a:rPr sz="4000" b="1" i="0">
+                <a:solidFill>
+                  <a:srgbClr val="FFFFFF"/>
+                </a:solidFill>
+                <a:latin typeface="Arial"/>
+              </a:rPr>
+              <a:t>Theorie-Input 1</a:t>
+            </a:r>
+          </a:p>
+        </p:txBody>
+      </p:sp>
+      <p:sp>
+        <p:nvSpPr>
+          <p:cNvPr id="6" name="TextBox 5"/>
+          <p:cNvSpPr txBox="1"/>
+          <p:nvPr/>
+        </p:nvSpPr>
+        <p:spPr>
+          <a:xfrm>
+            <a:off x="685800" y="4480560"/>
+            <a:ext cx="8653881" cy="1280160"/>
+          </a:xfrm>
+          <a:prstGeom prst="rect">
+            <a:avLst/>
+          </a:prstGeom>
+          <a:noFill/>
+        </p:spPr>
+        <p:txBody>
+          <a:bodyPr wrap="square">
+            <a:spAutoFit/>
+          </a:bodyPr>
+          <a:lstStyle/>
+          <a:p>
+            <a:pPr algn="l"/>
+            <a:r>
+              <a:rPr sz="1600" b="0" i="0">
+                <a:solidFill>
+                  <a:srgbClr val="C8D2E6"/>
+                </a:solidFill>
+                <a:latin typeface="Arial"/>
+              </a:rPr>
+              <a:t>Wichtigkeit und Dringlichkeit trennen – das Richtige zuerst tun.</a:t>
+            </a:r>
+          </a:p>
+        </p:txBody>
+      </p:sp>
+      <p:sp>
+        <p:nvSpPr>
+          <p:cNvPr id="7" name="TextBox 6"/>
+          <p:cNvSpPr txBox="1"/>
+          <p:nvPr/>
+        </p:nvSpPr>
+        <p:spPr>
+          <a:xfrm>
+            <a:off x="685800" y="6355080"/>
+            <a:ext cx="10817352" cy="274320"/>
           </a:xfrm>
           <a:prstGeom prst="rect">
             <a:avLst/>
@@ -6263,46 +9191,11 @@
             <a:r>
               <a:rPr sz="700">
                 <a:solidFill>
-                  <a:srgbClr val="A0B4D2"/>
+                  <a:srgbClr val="8CA0C3"/>
                 </a:solidFill>
                 <a:latin typeface="Consolas"/>
               </a:rPr>
               <a:t>FKB Campus  ·  VA08</a:t>
-            </a:r>
-          </a:p>
-        </p:txBody>
-      </p:sp>
-      <p:sp>
-        <p:nvSpPr>
-          <p:cNvPr id="10" name="TextBox 9"/>
-          <p:cNvSpPr txBox="1"/>
-          <p:nvPr/>
-        </p:nvSpPr>
-        <p:spPr>
-          <a:xfrm>
-            <a:off x="7176211" y="6583680"/>
-            <a:ext cx="4326940" cy="256032"/>
-          </a:xfrm>
-          <a:prstGeom prst="rect">
-            <a:avLst/>
-          </a:prstGeom>
-          <a:noFill/>
-        </p:spPr>
-        <p:txBody>
-          <a:bodyPr wrap="none">
-            <a:spAutoFit/>
-          </a:bodyPr>
-          <a:lstStyle/>
-          <a:p>
-            <a:pPr algn="r"/>
-            <a:r>
-              <a:rPr sz="700">
-                <a:solidFill>
-                  <a:srgbClr val="A0B4D2"/>
-                </a:solidFill>
-                <a:latin typeface="Consolas"/>
-              </a:rPr>
-              <a:t>Übersicht</a:t>
             </a:r>
           </a:p>
         </p:txBody>
@@ -6562,7 +9455,7 @@
                 </a:solidFill>
                 <a:latin typeface="Arial"/>
               </a:rPr>
-              <a:t>Theorie-Input: Zeitfresser und Unterbrechungen</a:t>
+              <a:t>Wichtig geht vor dringend</a:t>
             </a:r>
           </a:p>
         </p:txBody>
@@ -6588,6 +9481,25 @@
             <a:spAutoFit/>
           </a:bodyPr>
           <a:lstStyle/>
+          <a:p>
+            <a:pPr marL="177800" indent="-177800">
+              <a:spcBef>
+                <a:spcPts val="600"/>
+              </a:spcBef>
+              <a:spcAft>
+                <a:spcPts val="200"/>
+              </a:spcAft>
+            </a:pPr>
+            <a:r>
+              <a:rPr sz="1200" i="1">
+                <a:solidFill>
+                  <a:srgbClr val="3D5466"/>
+                </a:solidFill>
+                <a:latin typeface="Arial"/>
+              </a:rPr>
+              <a:t>→  Dringlichkeit kommt im Innendienst oft von außen. Wichtigkeit bemisst sich an Auswirkung auf Fristen, Kunden, Prozessqualität und Haftung – nicht an Lautstärke.</a:t>
+            </a:r>
+          </a:p>
           <a:p>
             <a:pPr marL="190500" indent="-190500">
               <a:spcBef>
@@ -6604,7 +9516,7 @@
                 </a:solidFill>
                 <a:latin typeface="Arial"/>
               </a:rPr>
-              <a:t>▸  Im Innendienst sind Unterbrechungen normal – das Problem ist der ständige Wechsel, der jedes Mal Einarbeitungszeit kostet. Drei wirksame Gegenmaßnahmen:</a:t>
+              <a:t>▸  Wichtig und dringend: sofort selbst tun.</a:t>
             </a:r>
           </a:p>
           <a:p>
@@ -6623,7 +9535,7 @@
                 </a:solidFill>
                 <a:latin typeface="Arial"/>
               </a:rPr>
-              <a:t>▸  Bündeln: gleichartige Aufgaben (z. B. alle Wiedervorlagen) am Stück erledigen.</a:t>
+              <a:t>▸  Wichtig, nicht dringend: terminieren und planen – hier entsteht Kontrolle.</a:t>
             </a:r>
           </a:p>
           <a:p>
@@ -6642,7 +9554,7 @@
                 </a:solidFill>
                 <a:latin typeface="Arial"/>
               </a:rPr>
-              <a:t>▸  Bearbeitungsblöcke: feste, störungsarme Zeitfenster für konzentrierte Arbeit.</a:t>
+              <a:t>▸  Nicht wichtig, aber dringend: kurz halten, abfangen, zurückrufen – Rückfragen ist keine Schwäche.</a:t>
             </a:r>
           </a:p>
           <a:p>
@@ -6661,26 +9573,7 @@
                 </a:solidFill>
                 <a:latin typeface="Arial"/>
               </a:rPr>
-              <a:t>▸  2-Minuten-Regel: Was in unter zwei Minuten erledigt ist, sofort tun; alles andere terminieren statt liegen lassen.</a:t>
-            </a:r>
-          </a:p>
-          <a:p>
-            <a:pPr marL="190500" indent="-190500">
-              <a:spcBef>
-                <a:spcPts val="400"/>
-              </a:spcBef>
-              <a:spcAft>
-                <a:spcPts val="200"/>
-              </a:spcAft>
-            </a:pPr>
-            <a:r>
-              <a:rPr sz="1300">
-                <a:solidFill>
-                  <a:srgbClr val="3D5466"/>
-                </a:solidFill>
-                <a:latin typeface="Arial"/>
-              </a:rPr>
-              <a:t>▸  Selbstorganisation ist eine Routine, die man aufbaut – nicht ein Charakterzug. Eigenverantwortliches Üben ist der Schlüssel (Knowles, 1975 ).</a:t>
+              <a:t>▸  Nicht wichtig und nicht dringend: bewusst weglassen.</a:t>
             </a:r>
           </a:p>
         </p:txBody>
@@ -6796,7 +9689,7 @@
             <a:avLst/>
           </a:prstGeom>
           <a:solidFill>
-            <a:srgbClr val="EDEDF3"/>
+            <a:srgbClr val="FFFFFF"/>
           </a:solidFill>
           <a:ln>
             <a:noFill/>
@@ -6897,51 +9790,43 @@
                 </a:solidFill>
                 <a:latin typeface="Consolas"/>
               </a:rPr>
-              <a:t>VA08  ·  ARBEITSBLATT</a:t>
-            </a:r>
-          </a:p>
-        </p:txBody>
-      </p:sp>
-      <p:sp>
-        <p:nvSpPr>
-          <p:cNvPr id="5" name="Rectangle 4"/>
-          <p:cNvSpPr/>
-          <p:nvPr/>
-        </p:nvSpPr>
-        <p:spPr>
-          <a:xfrm>
-            <a:off x="0" y="1234440"/>
-            <a:ext cx="12188952" cy="12700"/>
-          </a:xfrm>
-          <a:prstGeom prst="rect">
-            <a:avLst/>
-          </a:prstGeom>
-          <a:solidFill>
-            <a:srgbClr val="D8DFE4"/>
-          </a:solidFill>
-          <a:ln>
-            <a:noFill/>
-          </a:ln>
-        </p:spPr>
-        <p:style>
-          <a:lnRef idx="1">
-            <a:schemeClr val="accent1"/>
-          </a:lnRef>
-          <a:fillRef idx="3">
-            <a:schemeClr val="accent1"/>
-          </a:fillRef>
-          <a:effectRef idx="2">
-            <a:schemeClr val="accent1"/>
-          </a:effectRef>
-          <a:fontRef idx="minor">
-            <a:schemeClr val="lt1"/>
-          </a:fontRef>
-        </p:style>
-        <p:txBody>
-          <a:bodyPr rtlCol="0" anchor="ctr"/>
-          <a:lstStyle/>
-          <a:p>
-            <a:pPr algn="ctr"/>
+              <a:t>VA08  ·  SCHAUBILD</a:t>
+            </a:r>
+          </a:p>
+        </p:txBody>
+      </p:sp>
+      <p:sp>
+        <p:nvSpPr>
+          <p:cNvPr id="5" name="TextBox 4"/>
+          <p:cNvSpPr txBox="1"/>
+          <p:nvPr/>
+        </p:nvSpPr>
+        <p:spPr>
+          <a:xfrm>
+            <a:off x="685800" y="502920"/>
+            <a:ext cx="10817352" cy="594360"/>
+          </a:xfrm>
+          <a:prstGeom prst="rect">
+            <a:avLst/>
+          </a:prstGeom>
+          <a:noFill/>
+        </p:spPr>
+        <p:txBody>
+          <a:bodyPr wrap="square">
+            <a:spAutoFit/>
+          </a:bodyPr>
+          <a:lstStyle/>
+          <a:p>
+            <a:pPr algn="l"/>
+            <a:r>
+              <a:rPr sz="2000" b="1" i="0">
+                <a:solidFill>
+                  <a:srgbClr val="1F2C56"/>
+                </a:solidFill>
+                <a:latin typeface="Arial"/>
+              </a:rPr>
+              <a:t>Wichtig geht vor dringend</a:t>
+            </a:r>
           </a:p>
         </p:txBody>
       </p:sp>
@@ -6953,8 +9838,8 @@
         </p:nvSpPr>
         <p:spPr>
           <a:xfrm>
-            <a:off x="685800" y="502920"/>
-            <a:ext cx="36576" cy="658368"/>
+            <a:off x="685800" y="1143000"/>
+            <a:ext cx="10817352" cy="25400"/>
           </a:xfrm>
           <a:prstGeom prst="rect">
             <a:avLst/>
@@ -6988,240 +9873,33 @@
           </a:p>
         </p:txBody>
       </p:sp>
-      <p:sp>
-        <p:nvSpPr>
-          <p:cNvPr id="7" name="TextBox 6"/>
-          <p:cNvSpPr txBox="1"/>
-          <p:nvPr/>
-        </p:nvSpPr>
-        <p:spPr>
-          <a:xfrm>
-            <a:off x="813816" y="502920"/>
-            <a:ext cx="10634472" cy="685800"/>
-          </a:xfrm>
-          <a:prstGeom prst="rect">
-            <a:avLst/>
-          </a:prstGeom>
-          <a:noFill/>
-        </p:spPr>
-        <p:txBody>
-          <a:bodyPr wrap="square">
-            <a:spAutoFit/>
-          </a:bodyPr>
-          <a:lstStyle/>
-          <a:p>
-            <a:pPr algn="l"/>
-            <a:r>
-              <a:rPr sz="2400" b="1" i="0">
-                <a:solidFill>
-                  <a:srgbClr val="1F2C56"/>
-                </a:solidFill>
-                <a:latin typeface="Arial"/>
-              </a:rPr>
-              <a:t>Praxisfall: Ein Montagmorgen im Innendienst</a:t>
-            </a:r>
-          </a:p>
-        </p:txBody>
-      </p:sp>
-      <p:sp>
-        <p:nvSpPr>
-          <p:cNvPr id="8" name="TextBox 7"/>
-          <p:cNvSpPr txBox="1"/>
-          <p:nvPr/>
-        </p:nvSpPr>
-        <p:spPr>
-          <a:xfrm>
-            <a:off x="685800" y="1554480"/>
-            <a:ext cx="10817352" cy="3840480"/>
-          </a:xfrm>
-          <a:prstGeom prst="rect">
-            <a:avLst/>
-          </a:prstGeom>
-          <a:noFill/>
-        </p:spPr>
-        <p:txBody>
-          <a:bodyPr wrap="square">
-            <a:spAutoFit/>
-          </a:bodyPr>
-          <a:lstStyle/>
-          <a:p>
-            <a:pPr marL="190500" indent="-190500">
-              <a:spcBef>
-                <a:spcPts val="400"/>
-              </a:spcBef>
-              <a:spcAft>
-                <a:spcPts val="200"/>
-              </a:spcAft>
-            </a:pPr>
-            <a:r>
-              <a:rPr sz="1400">
-                <a:solidFill>
-                  <a:srgbClr val="3D5466"/>
-                </a:solidFill>
-                <a:latin typeface="Arial"/>
-              </a:rPr>
-              <a:t>▸  Ausgangslage (anonymisiert)</a:t>
-            </a:r>
-          </a:p>
-          <a:p>
-            <a:pPr marL="190500" indent="-190500">
-              <a:spcBef>
-                <a:spcPts val="400"/>
-              </a:spcBef>
-              <a:spcAft>
-                <a:spcPts val="200"/>
-              </a:spcAft>
-            </a:pPr>
-            <a:r>
-              <a:rPr sz="1400">
-                <a:solidFill>
-                  <a:srgbClr val="3D5466"/>
-                </a:solidFill>
-                <a:latin typeface="Arial"/>
-              </a:rPr>
-              <a:t>▸  Es ist Montag, 8:00 Uhr. Auf Ihrem Tisch (VR-Bank Musterregion eG) liegen gleichzeitig:</a:t>
-            </a:r>
-          </a:p>
-          <a:p>
-            <a:pPr marL="190500" indent="-190500">
-              <a:spcBef>
-                <a:spcPts val="400"/>
-              </a:spcBef>
-              <a:spcAft>
-                <a:spcPts val="200"/>
-              </a:spcAft>
-            </a:pPr>
-            <a:r>
-              <a:rPr sz="1400">
-                <a:solidFill>
-                  <a:srgbClr val="3D5466"/>
-                </a:solidFill>
-                <a:latin typeface="Arial"/>
-              </a:rPr>
-              <a:t>▸  Ein Berater bittet bis 11:00 Uhr um eine Engagementübersicht für einen Mittagstermin.</a:t>
-            </a:r>
-          </a:p>
-          <a:p>
-            <a:pPr marL="190500" indent="-190500">
-              <a:spcBef>
-                <a:spcPts val="400"/>
-              </a:spcBef>
-              <a:spcAft>
-                <a:spcPts val="200"/>
-              </a:spcAft>
-            </a:pPr>
-            <a:r>
-              <a:rPr sz="1400">
-                <a:solidFill>
-                  <a:srgbClr val="3D5466"/>
-                </a:solidFill>
-                <a:latin typeface="Arial"/>
-              </a:rPr>
-              <a:t>▸  Drei Wiedervorlagen sind heute fällig (fehlende BWA, Adressänderung, Sicherheitennachweis).</a:t>
-            </a:r>
-          </a:p>
-          <a:p>
-            <a:pPr marL="190500" indent="-190500">
-              <a:spcBef>
-                <a:spcPts val="400"/>
-              </a:spcBef>
-              <a:spcAft>
-                <a:spcPts val="200"/>
-              </a:spcAft>
-            </a:pPr>
-            <a:r>
-              <a:rPr sz="1400">
-                <a:solidFill>
-                  <a:srgbClr val="3D5466"/>
-                </a:solidFill>
-                <a:latin typeface="Arial"/>
-              </a:rPr>
-              <a:t>▸  Eine Kundin hat eine einfache Frage per Mail (2 Minuten).</a:t>
-            </a:r>
-          </a:p>
-        </p:txBody>
-      </p:sp>
-      <p:sp>
-        <p:nvSpPr>
-          <p:cNvPr id="9" name="Rectangle 8"/>
-          <p:cNvSpPr/>
-          <p:nvPr/>
-        </p:nvSpPr>
-        <p:spPr>
-          <a:xfrm>
-            <a:off x="685800" y="5486400"/>
-            <a:ext cx="10817352" cy="640080"/>
-          </a:xfrm>
-          <a:prstGeom prst="rect">
-            <a:avLst/>
-          </a:prstGeom>
-          <a:solidFill>
-            <a:srgbClr val="1F2C56"/>
-          </a:solidFill>
-          <a:ln>
-            <a:noFill/>
-          </a:ln>
-        </p:spPr>
-        <p:style>
-          <a:lnRef idx="1">
-            <a:schemeClr val="accent1"/>
-          </a:lnRef>
-          <a:fillRef idx="3">
-            <a:schemeClr val="accent1"/>
-          </a:fillRef>
-          <a:effectRef idx="2">
-            <a:schemeClr val="accent1"/>
-          </a:effectRef>
-          <a:fontRef idx="minor">
-            <a:schemeClr val="lt1"/>
-          </a:fontRef>
-        </p:style>
-        <p:txBody>
-          <a:bodyPr rtlCol="0" anchor="ctr"/>
-          <a:lstStyle/>
-          <a:p>
-            <a:pPr algn="ctr"/>
-          </a:p>
-        </p:txBody>
-      </p:sp>
-      <p:sp>
-        <p:nvSpPr>
-          <p:cNvPr id="10" name="TextBox 9"/>
-          <p:cNvSpPr txBox="1"/>
-          <p:nvPr/>
-        </p:nvSpPr>
-        <p:spPr>
-          <a:xfrm>
-            <a:off x="868680" y="5596128"/>
-            <a:ext cx="10451592" cy="457200"/>
-          </a:xfrm>
-          <a:prstGeom prst="rect">
-            <a:avLst/>
-          </a:prstGeom>
-          <a:noFill/>
-        </p:spPr>
-        <p:txBody>
-          <a:bodyPr wrap="square">
-            <a:spAutoFit/>
-          </a:bodyPr>
-          <a:lstStyle/>
-          <a:p>
-            <a:pPr algn="l"/>
-            <a:r>
-              <a:rPr sz="1300" b="1" i="0">
-                <a:solidFill>
-                  <a:srgbClr val="FFFFFF"/>
-                </a:solidFill>
-                <a:latin typeface="Arial"/>
-              </a:rPr>
-              <a:t>→  Bearbeitung im Teilnehmer-Workbook (Arbeitsblatt mit Ausfüllfeldern)</a:t>
-            </a:r>
-          </a:p>
-        </p:txBody>
-      </p:sp>
-      <p:sp>
-        <p:nvSpPr>
-          <p:cNvPr id="11" name="Rectangle 10"/>
+      <p:pic>
+        <p:nvPicPr>
+          <p:cNvPr id="7" name="Picture 6" descr="image.png"/>
+          <p:cNvPicPr>
+            <a:picLocks noChangeAspect="1"/>
+          </p:cNvPicPr>
+          <p:nvPr/>
+        </p:nvPicPr>
+        <p:blipFill>
+          <a:blip r:embed="rId2"/>
+          <a:stretch>
+            <a:fillRect/>
+          </a:stretch>
+        </p:blipFill>
+        <p:spPr>
+          <a:xfrm>
+            <a:off x="2009463" y="1325880"/>
+            <a:ext cx="8170026" cy="4937760"/>
+          </a:xfrm>
+          <a:prstGeom prst="rect">
+            <a:avLst/>
+          </a:prstGeom>
+        </p:spPr>
+      </p:pic>
+      <p:sp>
+        <p:nvSpPr>
+          <p:cNvPr id="8" name="Rectangle 7"/>
           <p:cNvSpPr/>
           <p:nvPr/>
         </p:nvSpPr>
@@ -7264,7 +9942,7 @@
       </p:sp>
       <p:sp>
         <p:nvSpPr>
-          <p:cNvPr id="12" name="TextBox 11"/>
+          <p:cNvPr id="9" name="TextBox 8"/>
           <p:cNvSpPr txBox="1"/>
           <p:nvPr/>
         </p:nvSpPr>
@@ -7293,6 +9971,41 @@
                 <a:latin typeface="Consolas"/>
               </a:rPr>
               <a:t>FKB Campus  ·  VA08</a:t>
+            </a:r>
+          </a:p>
+        </p:txBody>
+      </p:sp>
+      <p:sp>
+        <p:nvSpPr>
+          <p:cNvPr id="10" name="TextBox 9"/>
+          <p:cNvSpPr txBox="1"/>
+          <p:nvPr/>
+        </p:nvSpPr>
+        <p:spPr>
+          <a:xfrm>
+            <a:off x="7176211" y="6583680"/>
+            <a:ext cx="4326940" cy="256032"/>
+          </a:xfrm>
+          <a:prstGeom prst="rect">
+            <a:avLst/>
+          </a:prstGeom>
+          <a:noFill/>
+        </p:spPr>
+        <p:txBody>
+          <a:bodyPr wrap="none">
+            <a:spAutoFit/>
+          </a:bodyPr>
+          <a:lstStyle/>
+          <a:p>
+            <a:pPr algn="r"/>
+            <a:r>
+              <a:rPr sz="700">
+                <a:solidFill>
+                  <a:srgbClr val="A0B4D2"/>
+                </a:solidFill>
+                <a:latin typeface="Consolas"/>
+              </a:rPr>
+              <a:t>Schaubild</a:t>
             </a:r>
           </a:p>
         </p:txBody>
@@ -7330,6 +10043,250 @@
             <a:avLst/>
           </a:prstGeom>
           <a:solidFill>
+            <a:srgbClr val="1F2C56"/>
+          </a:solidFill>
+          <a:ln>
+            <a:noFill/>
+          </a:ln>
+        </p:spPr>
+        <p:style>
+          <a:lnRef idx="1">
+            <a:schemeClr val="accent1"/>
+          </a:lnRef>
+          <a:fillRef idx="3">
+            <a:schemeClr val="accent1"/>
+          </a:fillRef>
+          <a:effectRef idx="2">
+            <a:schemeClr val="accent1"/>
+          </a:effectRef>
+          <a:fontRef idx="minor">
+            <a:schemeClr val="lt1"/>
+          </a:fontRef>
+        </p:style>
+        <p:txBody>
+          <a:bodyPr rtlCol="0" anchor="ctr"/>
+          <a:lstStyle/>
+          <a:p>
+            <a:pPr algn="ctr"/>
+          </a:p>
+        </p:txBody>
+      </p:sp>
+      <p:sp>
+        <p:nvSpPr>
+          <p:cNvPr id="3" name="TextBox 2"/>
+          <p:cNvSpPr txBox="1"/>
+          <p:nvPr/>
+        </p:nvSpPr>
+        <p:spPr>
+          <a:xfrm>
+            <a:off x="685800" y="2377440"/>
+            <a:ext cx="10817352" cy="365760"/>
+          </a:xfrm>
+          <a:prstGeom prst="rect">
+            <a:avLst/>
+          </a:prstGeom>
+          <a:noFill/>
+        </p:spPr>
+        <p:txBody>
+          <a:bodyPr wrap="none">
+            <a:spAutoFit/>
+          </a:bodyPr>
+          <a:lstStyle/>
+          <a:p>
+            <a:pPr algn="l"/>
+            <a:r>
+              <a:rPr sz="1200">
+                <a:solidFill>
+                  <a:srgbClr val="D9C089"/>
+                </a:solidFill>
+                <a:latin typeface="Consolas"/>
+              </a:rPr>
+              <a:t>00:20–00:30</a:t>
+            </a:r>
+          </a:p>
+        </p:txBody>
+      </p:sp>
+      <p:sp>
+        <p:nvSpPr>
+          <p:cNvPr id="4" name="Rectangle 3"/>
+          <p:cNvSpPr/>
+          <p:nvPr/>
+        </p:nvSpPr>
+        <p:spPr>
+          <a:xfrm>
+            <a:off x="685800" y="2788920"/>
+            <a:ext cx="548640" cy="38100"/>
+          </a:xfrm>
+          <a:prstGeom prst="rect">
+            <a:avLst/>
+          </a:prstGeom>
+          <a:solidFill>
+            <a:srgbClr val="D9C089"/>
+          </a:solidFill>
+          <a:ln>
+            <a:noFill/>
+          </a:ln>
+        </p:spPr>
+        <p:style>
+          <a:lnRef idx="1">
+            <a:schemeClr val="accent1"/>
+          </a:lnRef>
+          <a:fillRef idx="3">
+            <a:schemeClr val="accent1"/>
+          </a:fillRef>
+          <a:effectRef idx="2">
+            <a:schemeClr val="accent1"/>
+          </a:effectRef>
+          <a:fontRef idx="minor">
+            <a:schemeClr val="lt1"/>
+          </a:fontRef>
+        </p:style>
+        <p:txBody>
+          <a:bodyPr rtlCol="0" anchor="ctr"/>
+          <a:lstStyle/>
+          <a:p>
+            <a:pPr algn="ctr"/>
+          </a:p>
+        </p:txBody>
+      </p:sp>
+      <p:sp>
+        <p:nvSpPr>
+          <p:cNvPr id="5" name="TextBox 4"/>
+          <p:cNvSpPr txBox="1"/>
+          <p:nvPr/>
+        </p:nvSpPr>
+        <p:spPr>
+          <a:xfrm>
+            <a:off x="685800" y="3017520"/>
+            <a:ext cx="10817352" cy="1463040"/>
+          </a:xfrm>
+          <a:prstGeom prst="rect">
+            <a:avLst/>
+          </a:prstGeom>
+          <a:noFill/>
+        </p:spPr>
+        <p:txBody>
+          <a:bodyPr wrap="square">
+            <a:spAutoFit/>
+          </a:bodyPr>
+          <a:lstStyle/>
+          <a:p>
+            <a:pPr algn="l"/>
+            <a:r>
+              <a:rPr sz="4000" b="1" i="0">
+                <a:solidFill>
+                  <a:srgbClr val="FFFFFF"/>
+                </a:solidFill>
+                <a:latin typeface="Arial"/>
+              </a:rPr>
+              <a:t>Theorie-Input 2</a:t>
+            </a:r>
+          </a:p>
+        </p:txBody>
+      </p:sp>
+      <p:sp>
+        <p:nvSpPr>
+          <p:cNvPr id="6" name="TextBox 5"/>
+          <p:cNvSpPr txBox="1"/>
+          <p:nvPr/>
+        </p:nvSpPr>
+        <p:spPr>
+          <a:xfrm>
+            <a:off x="685800" y="4480560"/>
+            <a:ext cx="8653881" cy="1280160"/>
+          </a:xfrm>
+          <a:prstGeom prst="rect">
+            <a:avLst/>
+          </a:prstGeom>
+          <a:noFill/>
+        </p:spPr>
+        <p:txBody>
+          <a:bodyPr wrap="square">
+            <a:spAutoFit/>
+          </a:bodyPr>
+          <a:lstStyle/>
+          <a:p>
+            <a:pPr algn="l"/>
+            <a:r>
+              <a:rPr sz="1600" b="0" i="0">
+                <a:solidFill>
+                  <a:srgbClr val="C8D2E6"/>
+                </a:solidFill>
+                <a:latin typeface="Arial"/>
+              </a:rPr>
+              <a:t>Zeitfresser erkennen und mit drei Techniken zerfasertes Arbeiten stoppen.</a:t>
+            </a:r>
+          </a:p>
+        </p:txBody>
+      </p:sp>
+      <p:sp>
+        <p:nvSpPr>
+          <p:cNvPr id="7" name="TextBox 6"/>
+          <p:cNvSpPr txBox="1"/>
+          <p:nvPr/>
+        </p:nvSpPr>
+        <p:spPr>
+          <a:xfrm>
+            <a:off x="685800" y="6355080"/>
+            <a:ext cx="10817352" cy="274320"/>
+          </a:xfrm>
+          <a:prstGeom prst="rect">
+            <a:avLst/>
+          </a:prstGeom>
+          <a:noFill/>
+        </p:spPr>
+        <p:txBody>
+          <a:bodyPr wrap="none">
+            <a:spAutoFit/>
+          </a:bodyPr>
+          <a:lstStyle/>
+          <a:p>
+            <a:pPr algn="l"/>
+            <a:r>
+              <a:rPr sz="700">
+                <a:solidFill>
+                  <a:srgbClr val="8CA0C3"/>
+                </a:solidFill>
+                <a:latin typeface="Consolas"/>
+              </a:rPr>
+              <a:t>FKB Campus  ·  VA08</a:t>
+            </a:r>
+          </a:p>
+        </p:txBody>
+      </p:sp>
+    </p:spTree>
+  </p:cSld>
+  <p:clrMapOvr>
+    <a:masterClrMapping/>
+  </p:clrMapOvr>
+</p:sld>
+</file>
+
+<file path=ppt/slides/slide9.xml><?xml version="1.0" encoding="utf-8"?>
+<p:sld xmlns:a="http://schemas.openxmlformats.org/drawingml/2006/main" xmlns:p="http://schemas.openxmlformats.org/presentationml/2006/main" xmlns:r="http://schemas.openxmlformats.org/officeDocument/2006/relationships">
+  <p:cSld>
+    <p:spTree>
+      <p:nvGrpSpPr>
+        <p:cNvPr id="1" name=""/>
+        <p:cNvGrpSpPr/>
+        <p:nvPr/>
+      </p:nvGrpSpPr>
+      <p:grpSpPr/>
+      <p:sp>
+        <p:nvSpPr>
+          <p:cNvPr id="2" name="Rectangle 1"/>
+          <p:cNvSpPr/>
+          <p:nvPr/>
+        </p:nvSpPr>
+        <p:spPr>
+          <a:xfrm>
+            <a:off x="0" y="0"/>
+            <a:ext cx="12188952" cy="6858000"/>
+          </a:xfrm>
+          <a:prstGeom prst="rect">
+            <a:avLst/>
+          </a:prstGeom>
+          <a:solidFill>
             <a:srgbClr val="EDEDF3"/>
           </a:solidFill>
           <a:ln>
@@ -7552,7 +10509,7 @@
                 </a:solidFill>
                 <a:latin typeface="Arial"/>
               </a:rPr>
-              <a:t>Reflexionsfragen</a:t>
+              <a:t>Drei Gegenmittel gegen Zerfaserung</a:t>
             </a:r>
           </a:p>
         </p:txBody>
@@ -7578,6 +10535,25 @@
             <a:spAutoFit/>
           </a:bodyPr>
           <a:lstStyle/>
+          <a:p>
+            <a:pPr marL="177800" indent="-177800">
+              <a:spcBef>
+                <a:spcPts val="600"/>
+              </a:spcBef>
+              <a:spcAft>
+                <a:spcPts val="200"/>
+              </a:spcAft>
+            </a:pPr>
+            <a:r>
+              <a:rPr sz="1200" i="1">
+                <a:solidFill>
+                  <a:srgbClr val="3D5466"/>
+                </a:solidFill>
+                <a:latin typeface="Arial"/>
+              </a:rPr>
+              <a:t>→  Aus zehn Zwei-Minuten-Aufgaben werden sonst zwanzig Minuten zerfasertes Arbeiten – Technik schlägt Disziplin.</a:t>
+            </a:r>
+          </a:p>
           <a:p>
             <a:pPr marL="190500" indent="-190500">
               <a:spcBef>
@@ -7594,7 +10570,7 @@
                 </a:solidFill>
                 <a:latin typeface="Arial"/>
               </a:rPr>
-              <a:t>▸  Welche „wichtig, nicht dringend"-Aufgabe schieben Sie regelmäßig vor sich her?</a:t>
+              <a:t>▸  Bündeln: gleichartige Aufgaben (z. B. alle Wiedervorlagen) am Stück erledigen.</a:t>
             </a:r>
           </a:p>
           <a:p>
@@ -7613,7 +10589,7 @@
                 </a:solidFill>
                 <a:latin typeface="Arial"/>
               </a:rPr>
-              <a:t>▸  Was ist Ihr größter Zeitfresser – und was hält Sie davon ab, ihn abzustellen?</a:t>
+              <a:t>▸  Bearbeitungsblock: störungsarme Fokuszeit – braucht eine Teamabsprache zur Telefonvertretung.</a:t>
             </a:r>
           </a:p>
           <a:p>
@@ -7632,7 +10608,7 @@
                 </a:solidFill>
                 <a:latin typeface="Arial"/>
               </a:rPr>
-              <a:t>▸  Wann in der Woche planen Sie bewusst – oder reagieren Sie nur?</a:t>
+              <a:t>▸  2-Minuten-Regel: was in unter zwei Minuten erledigt ist, sofort tun; alles andere terminieren.</a:t>
             </a:r>
           </a:p>
         </p:txBody>

</xml_diff>